<commit_message>
Clarify wear-themes chart as 100% stacked posture bars
Replace grouped bars with per-cohort 100%-stacked bars (benefit/both/
defensive/other) and plain-language slide text.

Co-Authored-By: Claude Opus 4.8 <noreply@anthropic.com>
Claude-Session: https://claude.ai/code/session_01QymyDZtVeN8NH7FTZdCR1b
</commit_message>
<xml_diff>
--- a/reports/Hybrid_Cord_Wear_Analysis.pptx
+++ b/reports/Hybrid_Cord_Wear_Analysis.pptx
@@ -3668,7 +3668,7 @@
               </a:defRPr>
             </a:pPr>
             <a:r>
-              <a:t>Wear Themes — Benefit vs. Defensive</a:t>
+              <a:t>Wear Posture — Claiming a Benefit vs. Fixing Uneven Wear</a:t>
             </a:r>
           </a:p>
         </p:txBody>
@@ -3689,8 +3689,8 @@
         </p:blipFill>
         <p:spPr>
           <a:xfrm>
-            <a:off x="6035040" y="1371600"/>
-            <a:ext cx="5852160" cy="3104557"/>
+            <a:off x="640080" y="1371600"/>
+            <a:ext cx="7680960" cy="3257728"/>
           </a:xfrm>
           <a:prstGeom prst="rect">
             <a:avLst/>
@@ -3705,8 +3705,8 @@
         </p:nvSpPr>
         <p:spPr>
           <a:xfrm>
-            <a:off x="548640" y="1463040"/>
-            <a:ext cx="5303520" cy="4572000"/>
+            <a:off x="8321040" y="1371600"/>
+            <a:ext cx="3566160" cy="4937760"/>
           </a:xfrm>
           <a:prstGeom prst="rect">
             <a:avLst/>
@@ -3723,14 +3723,14 @@
               <a:spcAft>
                 <a:spcPts val="500"/>
               </a:spcAft>
-              <a:defRPr sz="1600">
+              <a:defRPr sz="1400">
                 <a:solidFill>
                   <a:srgbClr val="1F3B57"/>
                 </a:solidFill>
               </a:defRPr>
             </a:pPr>
             <a:r>
-              <a:t>• General hybrid:  98 benefit-only · 44 both · 24 defensive-only.</a:t>
+              <a:t>• Each bar = 100% of that cohort's wear patents, split by what they claim.</a:t>
             </a:r>
           </a:p>
           <a:p>
@@ -3738,14 +3738,14 @@
               <a:spcAft>
                 <a:spcPts val="500"/>
               </a:spcAft>
-              <a:defRPr sz="1600">
-                <a:solidFill>
-                  <a:srgbClr val="1F3B57"/>
+              <a:defRPr sz="1200">
+                <a:solidFill>
+                  <a:srgbClr val="555555"/>
                 </a:solidFill>
               </a:defRPr>
             </a:pPr>
             <a:r>
-              <a:t>• Nylon-Aramid:  59 benefit-only · 10 both · 22 defensive-only.</a:t>
+              <a:t>   – Benefit only = a wear/mileage win, no problem mentioned.</a:t>
             </a:r>
           </a:p>
           <a:p>
@@ -3753,14 +3753,14 @@
               <a:spcAft>
                 <a:spcPts val="500"/>
               </a:spcAft>
-              <a:defRPr sz="1600">
-                <a:solidFill>
-                  <a:srgbClr val="1F3B57"/>
+              <a:defRPr sz="1200">
+                <a:solidFill>
+                  <a:srgbClr val="555555"/>
                 </a:solidFill>
               </a:defRPr>
             </a:pPr>
             <a:r>
-              <a:t>• Nylon-Aramid defensive-only (22) outnumbers its 'both' (10) — opposite of general hybrid.</a:t>
+              <a:t>   – Defensive = fixes uneven / irregular wear.</a:t>
             </a:r>
           </a:p>
           <a:p>
@@ -3768,14 +3768,44 @@
               <a:spcAft>
                 <a:spcPts val="500"/>
               </a:spcAft>
-              <a:defRPr sz="1600">
+              <a:defRPr sz="1400">
                 <a:solidFill>
                   <a:srgbClr val="1F3B57"/>
                 </a:solidFill>
               </a:defRPr>
             </a:pPr>
             <a:r>
-              <a:t>• Interpretation: high-modulus aramid raises circumferential stiffness, which both helps footprint uniformity AND can trigger uneven wear that must be engineered out.</a:t>
+              <a:t>• Nylon-Aramid is more defensive: 22 defensive-only vs only 10 'both'.</a:t>
+            </a:r>
+          </a:p>
+          <a:p>
+            <a:pPr>
+              <a:spcAft>
+                <a:spcPts val="500"/>
+              </a:spcAft>
+              <a:defRPr sz="1400">
+                <a:solidFill>
+                  <a:srgbClr val="1F3B57"/>
+                </a:solidFill>
+              </a:defRPr>
+            </a:pPr>
+            <a:r>
+              <a:t>• General hybrid is the reverse: 44 'both' vs 24 defensive-only.</a:t>
+            </a:r>
+          </a:p>
+          <a:p>
+            <a:pPr>
+              <a:spcAft>
+                <a:spcPts val="500"/>
+              </a:spcAft>
+              <a:defRPr sz="1400">
+                <a:solidFill>
+                  <a:srgbClr val="1F3B57"/>
+                </a:solidFill>
+              </a:defRPr>
+            </a:pPr>
+            <a:r>
+              <a:t>• Why: stiff aramid helps footprint uniformity, but its stiffness step can trigger uneven wear that must be engineered out.</a:t>
             </a:r>
           </a:p>
         </p:txBody>

</xml_diff>

<commit_message>
Expand deck with nylon-aramid solution deep-dive (11 slides)
Add slides: solution-approach chart, five recurring engineering solutions,
zoned-density live-art examples; white-space/FTO note in takeaways.

Co-Authored-By: Claude Opus 4.8 <noreply@anthropic.com>
Claude-Session: https://claude.ai/code/session_01QymyDZtVeN8NH7FTZdCR1b
</commit_message>
<xml_diff>
--- a/reports/Hybrid_Cord_Wear_Analysis.pptx
+++ b/reports/Hybrid_Cord_Wear_Analysis.pptx
@@ -13,6 +13,9 @@
     <p:sldId id="261" r:id="rId12"/>
     <p:sldId id="262" r:id="rId13"/>
     <p:sldId id="263" r:id="rId14"/>
+    <p:sldId id="264" r:id="rId15"/>
+    <p:sldId id="265" r:id="rId16"/>
+    <p:sldId id="266" r:id="rId17"/>
   </p:sldIdLst>
   <p:sldSz cx="12191695" cy="6858000" type="screen4x3"/>
   <p:notesSz cx="6858000" cy="9144000"/>
@@ -3158,6 +3161,394 @@
 </p:sld>
 </file>
 
+<file path=ppt/slides/slide10.xml><?xml version="1.0" encoding="utf-8"?>
+<p:sld xmlns:a="http://schemas.openxmlformats.org/drawingml/2006/main" xmlns:p="http://schemas.openxmlformats.org/presentationml/2006/main" xmlns:r="http://schemas.openxmlformats.org/officeDocument/2006/relationships">
+  <p:cSld>
+    <p:spTree>
+      <p:nvGrpSpPr>
+        <p:cNvPr id="1" name=""/>
+        <p:cNvGrpSpPr/>
+        <p:nvPr/>
+      </p:nvGrpSpPr>
+      <p:grpSpPr/>
+      <p:sp>
+        <p:nvSpPr>
+          <p:cNvPr id="2" name="Rectangle 1"/>
+          <p:cNvSpPr/>
+          <p:nvPr/>
+        </p:nvSpPr>
+        <p:spPr>
+          <a:xfrm>
+            <a:off x="0" y="0"/>
+            <a:ext cx="12191695" cy="164592"/>
+          </a:xfrm>
+          <a:prstGeom prst="rect">
+            <a:avLst/>
+          </a:prstGeom>
+          <a:solidFill>
+            <a:srgbClr val="1F3B57"/>
+          </a:solidFill>
+          <a:ln>
+            <a:noFill/>
+          </a:ln>
+        </p:spPr>
+        <p:style>
+          <a:lnRef idx="1">
+            <a:schemeClr val="accent1"/>
+          </a:lnRef>
+          <a:fillRef idx="3">
+            <a:schemeClr val="accent1"/>
+          </a:fillRef>
+          <a:effectRef idx="2">
+            <a:schemeClr val="accent1"/>
+          </a:effectRef>
+          <a:fontRef idx="minor">
+            <a:schemeClr val="lt1"/>
+          </a:fontRef>
+        </p:style>
+        <p:txBody>
+          <a:bodyPr rtlCol="0" anchor="ctr"/>
+          <a:lstStyle/>
+          <a:p>
+            <a:pPr algn="ctr"/>
+          </a:p>
+        </p:txBody>
+      </p:sp>
+      <p:sp>
+        <p:nvSpPr>
+          <p:cNvPr id="3" name="TextBox 2"/>
+          <p:cNvSpPr txBox="1"/>
+          <p:nvPr/>
+        </p:nvSpPr>
+        <p:spPr>
+          <a:xfrm>
+            <a:off x="457200" y="292608"/>
+            <a:ext cx="11247120" cy="822960"/>
+          </a:xfrm>
+          <a:prstGeom prst="rect">
+            <a:avLst/>
+          </a:prstGeom>
+          <a:noFill/>
+        </p:spPr>
+        <p:txBody>
+          <a:bodyPr wrap="square">
+            <a:spAutoFit/>
+          </a:bodyPr>
+          <a:lstStyle/>
+          <a:p>
+            <a:pPr>
+              <a:defRPr sz="2600" b="1">
+                <a:solidFill>
+                  <a:srgbClr val="1F3B57"/>
+                </a:solidFill>
+              </a:defRPr>
+            </a:pPr>
+            <a:r>
+              <a:t>The Uneven-Wear Fix: Zoned Density (live art)</a:t>
+            </a:r>
+          </a:p>
+        </p:txBody>
+      </p:sp>
+      <p:sp>
+        <p:nvSpPr>
+          <p:cNvPr id="4" name="TextBox 3"/>
+          <p:cNvSpPr txBox="1"/>
+          <p:nvPr/>
+        </p:nvSpPr>
+        <p:spPr>
+          <a:xfrm>
+            <a:off x="548640" y="1280160"/>
+            <a:ext cx="11155680" cy="5120640"/>
+          </a:xfrm>
+          <a:prstGeom prst="rect">
+            <a:avLst/>
+          </a:prstGeom>
+          <a:noFill/>
+        </p:spPr>
+        <p:txBody>
+          <a:bodyPr wrap="square">
+            <a:spAutoFit/>
+          </a:bodyPr>
+          <a:lstStyle/>
+          <a:p>
+            <a:pPr>
+              <a:spcAft>
+                <a:spcPts val="500"/>
+              </a:spcAft>
+              <a:defRPr sz="1500">
+                <a:solidFill>
+                  <a:srgbClr val="1F3B57"/>
+                </a:solidFill>
+              </a:defRPr>
+            </a:pPr>
+            <a:r>
+              <a:t>• Continental EP3912833A1 (ALIVE): centre PET at 120 EPDM + PA4.6 side sections at 130 EPDM.</a:t>
+            </a:r>
+          </a:p>
+          <a:p>
+            <a:pPr>
+              <a:spcAft>
+                <a:spcPts val="500"/>
+              </a:spcAft>
+              <a:defRPr sz="1500">
+                <a:solidFill>
+                  <a:srgbClr val="1F3B57"/>
+                </a:solidFill>
+              </a:defRPr>
+            </a:pPr>
+            <a:r>
+              <a:t>• Continental DE102016223304B4 (ALIVE): 3-section bandage, centre PA6.6 (470x2) + side sections for 'more uniform abrasion'.</a:t>
+            </a:r>
+          </a:p>
+          <a:p>
+            <a:pPr>
+              <a:spcAft>
+                <a:spcPts val="500"/>
+              </a:spcAft>
+              <a:defRPr sz="1500">
+                <a:solidFill>
+                  <a:srgbClr val="1F3B57"/>
+                </a:solidFill>
+              </a:defRPr>
+            </a:pPr>
+            <a:r>
+              <a:t>• Sumitomo JP2018184071A (ALIVE): centre low density (Ec) + shoulder high density (Em) → even stiffness across the tread.</a:t>
+            </a:r>
+          </a:p>
+          <a:p>
+            <a:pPr>
+              <a:spcAft>
+                <a:spcPts val="500"/>
+              </a:spcAft>
+              <a:defRPr sz="1500">
+                <a:solidFill>
+                  <a:srgbClr val="1F3B57"/>
+                </a:solidFill>
+              </a:defRPr>
+            </a:pPr>
+            <a:r>
+              <a:t>• Continental EP2048005B1 (ALIVE): tuned radius-to-width ratios so the stiffness discontinuity doesn't land at wear-initiation sites.</a:t>
+            </a:r>
+          </a:p>
+          <a:p>
+            <a:pPr>
+              <a:spcAft>
+                <a:spcPts val="500"/>
+              </a:spcAft>
+              <a:defRPr sz="1500">
+                <a:solidFill>
+                  <a:srgbClr val="1F3B57"/>
+                </a:solidFill>
+              </a:defRPr>
+            </a:pPr>
+            <a:r>
+              <a:t>• Implication: the defensible path is stiffness PLACEMENT (zoning / grading), not a harder cord — and Continental &amp; Sumitomo already hold live art here.</a:t>
+            </a:r>
+          </a:p>
+        </p:txBody>
+      </p:sp>
+    </p:spTree>
+  </p:cSld>
+  <p:clrMapOvr>
+    <a:masterClrMapping/>
+  </p:clrMapOvr>
+</p:sld>
+</file>
+
+<file path=ppt/slides/slide11.xml><?xml version="1.0" encoding="utf-8"?>
+<p:sld xmlns:a="http://schemas.openxmlformats.org/drawingml/2006/main" xmlns:p="http://schemas.openxmlformats.org/presentationml/2006/main" xmlns:r="http://schemas.openxmlformats.org/officeDocument/2006/relationships">
+  <p:cSld>
+    <p:spTree>
+      <p:nvGrpSpPr>
+        <p:cNvPr id="1" name=""/>
+        <p:cNvGrpSpPr/>
+        <p:nvPr/>
+      </p:nvGrpSpPr>
+      <p:grpSpPr/>
+      <p:sp>
+        <p:nvSpPr>
+          <p:cNvPr id="2" name="Rectangle 1"/>
+          <p:cNvSpPr/>
+          <p:nvPr/>
+        </p:nvSpPr>
+        <p:spPr>
+          <a:xfrm>
+            <a:off x="0" y="0"/>
+            <a:ext cx="12191695" cy="164592"/>
+          </a:xfrm>
+          <a:prstGeom prst="rect">
+            <a:avLst/>
+          </a:prstGeom>
+          <a:solidFill>
+            <a:srgbClr val="1F3B57"/>
+          </a:solidFill>
+          <a:ln>
+            <a:noFill/>
+          </a:ln>
+        </p:spPr>
+        <p:style>
+          <a:lnRef idx="1">
+            <a:schemeClr val="accent1"/>
+          </a:lnRef>
+          <a:fillRef idx="3">
+            <a:schemeClr val="accent1"/>
+          </a:fillRef>
+          <a:effectRef idx="2">
+            <a:schemeClr val="accent1"/>
+          </a:effectRef>
+          <a:fontRef idx="minor">
+            <a:schemeClr val="lt1"/>
+          </a:fontRef>
+        </p:style>
+        <p:txBody>
+          <a:bodyPr rtlCol="0" anchor="ctr"/>
+          <a:lstStyle/>
+          <a:p>
+            <a:pPr algn="ctr"/>
+          </a:p>
+        </p:txBody>
+      </p:sp>
+      <p:sp>
+        <p:nvSpPr>
+          <p:cNvPr id="3" name="TextBox 2"/>
+          <p:cNvSpPr txBox="1"/>
+          <p:nvPr/>
+        </p:nvSpPr>
+        <p:spPr>
+          <a:xfrm>
+            <a:off x="457200" y="292608"/>
+            <a:ext cx="11247120" cy="822960"/>
+          </a:xfrm>
+          <a:prstGeom prst="rect">
+            <a:avLst/>
+          </a:prstGeom>
+          <a:noFill/>
+        </p:spPr>
+        <p:txBody>
+          <a:bodyPr wrap="square">
+            <a:spAutoFit/>
+          </a:bodyPr>
+          <a:lstStyle/>
+          <a:p>
+            <a:pPr>
+              <a:defRPr sz="2600" b="1">
+                <a:solidFill>
+                  <a:srgbClr val="1F3B57"/>
+                </a:solidFill>
+              </a:defRPr>
+            </a:pPr>
+            <a:r>
+              <a:t>Takeaways &amp; Recommendations</a:t>
+            </a:r>
+          </a:p>
+        </p:txBody>
+      </p:sp>
+      <p:sp>
+        <p:nvSpPr>
+          <p:cNvPr id="4" name="TextBox 3"/>
+          <p:cNvSpPr txBox="1"/>
+          <p:nvPr/>
+        </p:nvSpPr>
+        <p:spPr>
+          <a:xfrm>
+            <a:off x="548640" y="1280160"/>
+            <a:ext cx="11064240" cy="5120640"/>
+          </a:xfrm>
+          <a:prstGeom prst="rect">
+            <a:avLst/>
+          </a:prstGeom>
+          <a:noFill/>
+        </p:spPr>
+        <p:txBody>
+          <a:bodyPr wrap="square">
+            <a:spAutoFit/>
+          </a:bodyPr>
+          <a:lstStyle/>
+          <a:p>
+            <a:pPr>
+              <a:spcAft>
+                <a:spcPts val="500"/>
+              </a:spcAft>
+              <a:defRPr sz="1500">
+                <a:solidFill>
+                  <a:srgbClr val="1F3B57"/>
+                </a:solidFill>
+              </a:defRPr>
+            </a:pPr>
+            <a:r>
+              <a:t>• Wear/mileage is a SECONDARY, indirect benefit of hybrid zero-degree cords — led by stiffness and footprint control.</a:t>
+            </a:r>
+          </a:p>
+          <a:p>
+            <a:pPr>
+              <a:spcAft>
+                <a:spcPts val="500"/>
+              </a:spcAft>
+              <a:defRPr sz="1500">
+                <a:solidFill>
+                  <a:srgbClr val="1F3B57"/>
+                </a:solidFill>
+              </a:defRPr>
+            </a:pPr>
+            <a:r>
+              <a:t>• For Nylon-Aramid specifically, manage the uneven-wear risk: the stiffness step at the cap-ply edge / over the reinforcing layer drives irregular wear.</a:t>
+            </a:r>
+          </a:p>
+          <a:p>
+            <a:pPr>
+              <a:spcAft>
+                <a:spcPts val="500"/>
+              </a:spcAft>
+              <a:defRPr sz="1500">
+                <a:solidFill>
+                  <a:srgbClr val="1F3B57"/>
+                </a:solidFill>
+              </a:defRPr>
+            </a:pPr>
+            <a:r>
+              <a:t>• Design levers in the IP: dual-modulus cord, twist tuning, adhesion/dip, zoned/two-layer bandage, positioning vs. grooves.</a:t>
+            </a:r>
+          </a:p>
+          <a:p>
+            <a:pPr>
+              <a:spcAft>
+                <a:spcPts val="500"/>
+              </a:spcAft>
+              <a:defRPr sz="1500">
+                <a:solidFill>
+                  <a:srgbClr val="1F3B57"/>
+                </a:solidFill>
+              </a:defRPr>
+            </a:pPr>
+            <a:r>
+              <a:t>• White space is narrow: zoned-density / modulus-grading is the proven path but Continental &amp; Sumitomo hold live art — check freedom-to-operate.</a:t>
+            </a:r>
+          </a:p>
+          <a:p>
+            <a:pPr>
+              <a:spcAft>
+                <a:spcPts val="500"/>
+              </a:spcAft>
+              <a:defRPr sz="1500">
+                <a:solidFill>
+                  <a:srgbClr val="1F3B57"/>
+                </a:solidFill>
+              </a:defRPr>
+            </a:pPr>
+            <a:r>
+              <a:t>• Next: tighten the Nylon-Aramid set to explicit co-twisted constructions; add rolling-resistance and high-speed-durability axes.</a:t>
+            </a:r>
+          </a:p>
+        </p:txBody>
+      </p:sp>
+    </p:spTree>
+  </p:cSld>
+  <p:clrMapOvr>
+    <a:masterClrMapping/>
+  </p:clrMapOvr>
+</p:sld>
+</file>
+
 <file path=ppt/slides/slide2.xml><?xml version="1.0" encoding="utf-8"?>
 <p:sld xmlns:a="http://schemas.openxmlformats.org/drawingml/2006/main" xmlns:p="http://schemas.openxmlformats.org/presentationml/2006/main" xmlns:r="http://schemas.openxmlformats.org/officeDocument/2006/relationships">
   <p:cSld>
@@ -4591,21 +4982,45 @@
               </a:defRPr>
             </a:pPr>
             <a:r>
-              <a:t>Takeaways &amp; Recommendations</a:t>
-            </a:r>
-          </a:p>
-        </p:txBody>
-      </p:sp>
-      <p:sp>
-        <p:nvSpPr>
-          <p:cNvPr id="4" name="TextBox 3"/>
+              <a:t>Deep Dive — How Nylon-Aramid Patents Solve Wear</a:t>
+            </a:r>
+          </a:p>
+        </p:txBody>
+      </p:sp>
+      <p:pic>
+        <p:nvPicPr>
+          <p:cNvPr id="4" name="Picture 3" descr="deck_solutions.png"/>
+          <p:cNvPicPr>
+            <a:picLocks noChangeAspect="1"/>
+          </p:cNvPicPr>
+          <p:nvPr/>
+        </p:nvPicPr>
+        <p:blipFill>
+          <a:blip r:embed="rId2"/>
+          <a:stretch>
+            <a:fillRect/>
+          </a:stretch>
+        </p:blipFill>
+        <p:spPr>
+          <a:xfrm>
+            <a:off x="5852160" y="1280160"/>
+            <a:ext cx="6035040" cy="3227941"/>
+          </a:xfrm>
+          <a:prstGeom prst="rect">
+            <a:avLst/>
+          </a:prstGeom>
+        </p:spPr>
+      </p:pic>
+      <p:sp>
+        <p:nvSpPr>
+          <p:cNvPr id="5" name="TextBox 4"/>
           <p:cNvSpPr txBox="1"/>
           <p:nvPr/>
         </p:nvSpPr>
         <p:spPr>
           <a:xfrm>
-            <a:off x="548640" y="1280160"/>
-            <a:ext cx="11064240" cy="5120640"/>
+            <a:off x="548640" y="1463040"/>
+            <a:ext cx="5029200" cy="4754880"/>
           </a:xfrm>
           <a:prstGeom prst="rect">
             <a:avLst/>
@@ -4622,14 +5037,14 @@
               <a:spcAft>
                 <a:spcPts val="500"/>
               </a:spcAft>
-              <a:defRPr sz="1600">
+              <a:defRPr sz="1500">
                 <a:solidFill>
                   <a:srgbClr val="1F3B57"/>
                 </a:solidFill>
               </a:defRPr>
             </a:pPr>
             <a:r>
-              <a:t>• Wear/mileage is a SECONDARY, indirect benefit of hybrid zero-degree cords — led by stiffness and footprint control.</a:t>
+              <a:t>• Researchers rarely chase abrasion resistance directly.</a:t>
             </a:r>
           </a:p>
           <a:p>
@@ -4637,14 +5052,14 @@
               <a:spcAft>
                 <a:spcPts val="500"/>
               </a:spcAft>
-              <a:defRPr sz="1600">
+              <a:defRPr sz="1500">
                 <a:solidFill>
                   <a:srgbClr val="1F3B57"/>
                 </a:solidFill>
               </a:defRPr>
             </a:pPr>
             <a:r>
-              <a:t>• For Nylon-Aramid specifically, manage the uneven-wear risk: the stiffness step at the cap-ply edge/over the reinforcing layer drives irregular wear.</a:t>
+              <a:t>• The strategy: make the contact patch uniform &amp; dimensionally stable.</a:t>
             </a:r>
           </a:p>
           <a:p>
@@ -4652,14 +5067,14 @@
               <a:spcAft>
                 <a:spcPts val="500"/>
               </a:spcAft>
-              <a:defRPr sz="1600">
+              <a:defRPr sz="1500">
                 <a:solidFill>
                   <a:srgbClr val="1F3B57"/>
                 </a:solidFill>
               </a:defRPr>
             </a:pPr>
             <a:r>
-              <a:t>• Design levers seen in the IP: zoned / variable-pitch bandage, side vs. centre cord density, modulus tuning, positioning relative to grooves.</a:t>
+              <a:t>• Aramid gives hoop stiffness → restrains crown growth → stable tread geometry → less slip/squirm wear.</a:t>
             </a:r>
           </a:p>
           <a:p>
@@ -4667,29 +5082,238 @@
               <a:spcAft>
                 <a:spcPts val="500"/>
               </a:spcAft>
-              <a:defRPr sz="1600">
+              <a:defRPr sz="1500">
                 <a:solidFill>
                   <a:srgbClr val="1F3B57"/>
                 </a:solidFill>
               </a:defRPr>
             </a:pPr>
             <a:r>
-              <a:t>• Watch the ALIVE Continental / Kumho / Sumitomo families for current art.</a:t>
-            </a:r>
-          </a:p>
+              <a:t>• But aramid's stiffness step itself causes uneven wear — so most IP is about placing &amp; grading that stiffness.</a:t>
+            </a:r>
+          </a:p>
+        </p:txBody>
+      </p:sp>
+    </p:spTree>
+  </p:cSld>
+  <p:clrMapOvr>
+    <a:masterClrMapping/>
+  </p:clrMapOvr>
+</p:sld>
+</file>
+
+<file path=ppt/slides/slide9.xml><?xml version="1.0" encoding="utf-8"?>
+<p:sld xmlns:a="http://schemas.openxmlformats.org/drawingml/2006/main" xmlns:p="http://schemas.openxmlformats.org/presentationml/2006/main" xmlns:r="http://schemas.openxmlformats.org/officeDocument/2006/relationships">
+  <p:cSld>
+    <p:spTree>
+      <p:nvGrpSpPr>
+        <p:cNvPr id="1" name=""/>
+        <p:cNvGrpSpPr/>
+        <p:nvPr/>
+      </p:nvGrpSpPr>
+      <p:grpSpPr/>
+      <p:sp>
+        <p:nvSpPr>
+          <p:cNvPr id="2" name="Rectangle 1"/>
+          <p:cNvSpPr/>
+          <p:nvPr/>
+        </p:nvSpPr>
+        <p:spPr>
+          <a:xfrm>
+            <a:off x="0" y="0"/>
+            <a:ext cx="12191695" cy="164592"/>
+          </a:xfrm>
+          <a:prstGeom prst="rect">
+            <a:avLst/>
+          </a:prstGeom>
+          <a:solidFill>
+            <a:srgbClr val="1F3B57"/>
+          </a:solidFill>
+          <a:ln>
+            <a:noFill/>
+          </a:ln>
+        </p:spPr>
+        <p:style>
+          <a:lnRef idx="1">
+            <a:schemeClr val="accent1"/>
+          </a:lnRef>
+          <a:fillRef idx="3">
+            <a:schemeClr val="accent1"/>
+          </a:fillRef>
+          <a:effectRef idx="2">
+            <a:schemeClr val="accent1"/>
+          </a:effectRef>
+          <a:fontRef idx="minor">
+            <a:schemeClr val="lt1"/>
+          </a:fontRef>
+        </p:style>
+        <p:txBody>
+          <a:bodyPr rtlCol="0" anchor="ctr"/>
+          <a:lstStyle/>
+          <a:p>
+            <a:pPr algn="ctr"/>
+          </a:p>
+        </p:txBody>
+      </p:sp>
+      <p:sp>
+        <p:nvSpPr>
+          <p:cNvPr id="3" name="TextBox 2"/>
+          <p:cNvSpPr txBox="1"/>
+          <p:nvPr/>
+        </p:nvSpPr>
+        <p:spPr>
+          <a:xfrm>
+            <a:off x="457200" y="292608"/>
+            <a:ext cx="11247120" cy="822960"/>
+          </a:xfrm>
+          <a:prstGeom prst="rect">
+            <a:avLst/>
+          </a:prstGeom>
+          <a:noFill/>
+        </p:spPr>
+        <p:txBody>
+          <a:bodyPr wrap="square">
+            <a:spAutoFit/>
+          </a:bodyPr>
+          <a:lstStyle/>
+          <a:p>
+            <a:pPr>
+              <a:defRPr sz="2600" b="1">
+                <a:solidFill>
+                  <a:srgbClr val="1F3B57"/>
+                </a:solidFill>
+              </a:defRPr>
+            </a:pPr>
+            <a:r>
+              <a:t>Five Recurring Engineering Solutions</a:t>
+            </a:r>
+          </a:p>
+        </p:txBody>
+      </p:sp>
+      <p:sp>
+        <p:nvSpPr>
+          <p:cNvPr id="4" name="TextBox 3"/>
+          <p:cNvSpPr txBox="1"/>
+          <p:nvPr/>
+        </p:nvSpPr>
+        <p:spPr>
+          <a:xfrm>
+            <a:off x="548640" y="1234440"/>
+            <a:ext cx="11155680" cy="5212080"/>
+          </a:xfrm>
+          <a:prstGeom prst="rect">
+            <a:avLst/>
+          </a:prstGeom>
+          <a:noFill/>
+        </p:spPr>
+        <p:txBody>
+          <a:bodyPr wrap="square">
+            <a:spAutoFit/>
+          </a:bodyPr>
+          <a:lstStyle/>
           <a:p>
             <a:pPr>
               <a:spcAft>
                 <a:spcPts val="500"/>
               </a:spcAft>
-              <a:defRPr sz="1600">
+              <a:defRPr sz="1400">
                 <a:solidFill>
                   <a:srgbClr val="1F3B57"/>
                 </a:solidFill>
               </a:defRPr>
             </a:pPr>
             <a:r>
-              <a:t>• Next: tighten the Nylon-Aramid set to explicit co-twisted constructions; add rolling-resistance and high-speed-durability axes.</a:t>
+              <a:t>• 1. Dual-modulus / core-sheath cord (51%) — low-mod core (nylon/rayon/PET) + high-mod aramid sheath; soft to build, stiff in service.</a:t>
+            </a:r>
+          </a:p>
+          <a:p>
+            <a:pPr>
+              <a:spcAft>
+                <a:spcPts val="500"/>
+              </a:spcAft>
+              <a:defRPr sz="1200">
+                <a:solidFill>
+                  <a:srgbClr val="555555"/>
+                </a:solidFill>
+              </a:defRPr>
+            </a:pPr>
+            <a:r>
+              <a:t>   – Goodyear EP2380755A2 (ALIVE): low-modulus core, 5–15 TPI, high-modulus outer filament.</a:t>
+            </a:r>
+          </a:p>
+          <a:p>
+            <a:pPr>
+              <a:spcAft>
+                <a:spcPts val="500"/>
+              </a:spcAft>
+              <a:defRPr sz="1400">
+                <a:solidFill>
+                  <a:srgbClr val="1F3B57"/>
+                </a:solidFill>
+              </a:defRPr>
+            </a:pPr>
+            <a:r>
+              <a:t>• 2. Twist / cord-geometry tuning (64%) — twist, denier, filament count set where the modulus transition occurs.</a:t>
+            </a:r>
+          </a:p>
+          <a:p>
+            <a:pPr>
+              <a:spcAft>
+                <a:spcPts val="500"/>
+              </a:spcAft>
+              <a:defRPr sz="1400">
+                <a:solidFill>
+                  <a:srgbClr val="1F3B57"/>
+                </a:solidFill>
+              </a:defRPr>
+            </a:pPr>
+            <a:r>
+              <a:t>• 3. Adhesion / dip engineering (61%) — epoxy pre-dip + RFL; less cord-rubber slip → less wear &amp; edge separation.</a:t>
+            </a:r>
+          </a:p>
+          <a:p>
+            <a:pPr>
+              <a:spcAft>
+                <a:spcPts val="500"/>
+              </a:spcAft>
+              <a:defRPr sz="1200">
+                <a:solidFill>
+                  <a:srgbClr val="555555"/>
+                </a:solidFill>
+              </a:defRPr>
+            </a:pPr>
+            <a:r>
+              <a:t>   – Goodyear US20160288575A1: single-end-dipped (SED) cords, no calendering.</a:t>
+            </a:r>
+          </a:p>
+          <a:p>
+            <a:pPr>
+              <a:spcAft>
+                <a:spcPts val="500"/>
+              </a:spcAft>
+              <a:defRPr sz="1400">
+                <a:solidFill>
+                  <a:srgbClr val="1F3B57"/>
+                </a:solidFill>
+              </a:defRPr>
+            </a:pPr>
+            <a:r>
+              <a:t>• 4. Zoned / two-layer overlay (46%) — different cord/density across tread width to equalise contact pressure (the uneven-wear fix).</a:t>
+            </a:r>
+          </a:p>
+          <a:p>
+            <a:pPr>
+              <a:spcAft>
+                <a:spcPts val="500"/>
+              </a:spcAft>
+              <a:defRPr sz="1400">
+                <a:solidFill>
+                  <a:srgbClr val="1F3B57"/>
+                </a:solidFill>
+              </a:defRPr>
+            </a:pPr>
+            <a:r>
+              <a:t>• 5. Positioning vs. grooves &amp; geometry ratios (20%) — keep the stiffness step away from where wear initiates.</a:t>
             </a:r>
           </a:p>
         </p:txBody>

</xml_diff>

<commit_message>
Pre-publication audit: correct cohorts, motorcycle exclusion, honest solutions chart
- scripts/cohorts.py: single source of truth for audited definitions
  (drop 92 primary-motorcycle; strict hybrid-cord cohorts)
- corrected numbers: corpus 1172->1080, general 507->156 (wear 199->54),
  nylon-aramid 318->100 (wear 115->31)
- solutions chart reframed as enrichment vs baseline (only core-sheath/
  dual-modulus/twist are distinctive); zoned-density flagged as PET/PA
- swapped invalid (motorcycle / PET-PA) example patents
- deck rebuilt (10 slides) with Limitations slide; reports/ANALYSIS_AUDIT.md

Co-Authored-By: Claude Opus 4.8 <noreply@anthropic.com>
Claude-Session: https://claude.ai/code/session_01QymyDZtVeN8NH7FTZdCR1b
</commit_message>
<xml_diff>
--- a/reports/Hybrid_Cord_Wear_Analysis.pptx
+++ b/reports/Hybrid_Cord_Wear_Analysis.pptx
@@ -15,7 +15,6 @@
     <p:sldId id="263" r:id="rId14"/>
     <p:sldId id="264" r:id="rId15"/>
     <p:sldId id="265" r:id="rId16"/>
-    <p:sldId id="266" r:id="rId17"/>
   </p:sldIdLst>
   <p:sldSz cx="12191695" cy="6858000" type="screen4x3"/>
   <p:notesSz cx="6858000" cy="9144000"/>
@@ -3114,8 +3113,8 @@
         </p:nvSpPr>
         <p:spPr>
           <a:xfrm>
-            <a:off x="822960" y="2286000"/>
-            <a:ext cx="10515600" cy="2286000"/>
+            <a:off x="822960" y="2194560"/>
+            <a:ext cx="10515600" cy="2743200"/>
           </a:xfrm>
           <a:prstGeom prst="rect">
             <a:avLst/>
@@ -3129,26 +3128,26 @@
           <a:lstStyle/>
           <a:p>
             <a:pPr>
-              <a:defRPr sz="4000" b="1">
+              <a:defRPr sz="3800" b="1">
                 <a:solidFill>
                   <a:srgbClr val="FFFFFF"/>
                 </a:solidFill>
               </a:defRPr>
             </a:pPr>
             <a:r>
-              <a:t>Hybrid Cord Patents — Wear / Mileage Analysis</a:t>
-            </a:r>
-          </a:p>
-          <a:p>
-            <a:pPr>
-              <a:defRPr sz="2000">
+              <a:t>Hybrid Cord Patents — Wear Analysis</a:t>
+            </a:r>
+          </a:p>
+          <a:p>
+            <a:pPr>
+              <a:defRPr sz="1800">
                 <a:solidFill>
                   <a:srgbClr val="BFD3E6"/>
                 </a:solidFill>
               </a:defRPr>
             </a:pPr>
             <a:r>
-              <a:t>Zero-degree belt cords in PCR tires · General hybrid vs. Nylon-Aramid · PatSeer landscape, 1,172 PCR patents</a:t>
+              <a:t>Zero-degree belt cords in PCR tires · General hybrid vs. Nylon-Aramid · 1080 PCR patents (audited, motorcycle-excluded)</a:t>
             </a:r>
           </a:p>
         </p:txBody>
@@ -3222,7 +3221,7 @@
         </p:nvSpPr>
         <p:spPr>
           <a:xfrm>
-            <a:off x="457200" y="292608"/>
+            <a:off x="457200" y="274320"/>
             <a:ext cx="11247120" cy="822960"/>
           </a:xfrm>
           <a:prstGeom prst="rect">
@@ -3237,14 +3236,14 @@
           <a:lstStyle/>
           <a:p>
             <a:pPr>
-              <a:defRPr sz="2600" b="1">
+              <a:defRPr sz="2500" b="1">
                 <a:solidFill>
                   <a:srgbClr val="1F3B57"/>
                 </a:solidFill>
               </a:defRPr>
             </a:pPr>
             <a:r>
-              <a:t>The Uneven-Wear Fix: Zoned Density (live art)</a:t>
+              <a:t>Takeaways &amp; Recommendations</a:t>
             </a:r>
           </a:p>
         </p:txBody>
@@ -3258,7 +3257,7 @@
         <p:spPr>
           <a:xfrm>
             <a:off x="548640" y="1280160"/>
-            <a:ext cx="11155680" cy="5120640"/>
+            <a:ext cx="11064240" cy="5120640"/>
           </a:xfrm>
           <a:prstGeom prst="rect">
             <a:avLst/>
@@ -3282,7 +3281,7 @@
               </a:defRPr>
             </a:pPr>
             <a:r>
-              <a:t>• Continental EP3912833A1 (ALIVE): centre PET at 120 EPDM + PA4.6 side sections at 130 EPDM.</a:t>
+              <a:t>• Wear/mileage is a secondary, indirect benefit of Nylon-Aramid zero-degree cords — via stiffness and footprint control.</a:t>
             </a:r>
           </a:p>
           <a:p>
@@ -3297,7 +3296,7 @@
               </a:defRPr>
             </a:pPr>
             <a:r>
-              <a:t>• Continental DE102016223304B4 (ALIVE): 3-section bandage, centre PA6.6 (470x2) + side sections for 'more uniform abrasion'.</a:t>
+              <a:t>• The Nylon-Aramid wear lever is the CORD: core-sheath, dual-modulus, twist tuning — not zoned density (that is PET/PA).</a:t>
             </a:r>
           </a:p>
           <a:p>
@@ -3312,7 +3311,7 @@
               </a:defRPr>
             </a:pPr>
             <a:r>
-              <a:t>• Sumitomo JP2018184071A (ALIVE): centre low density (Ec) + shoulder high density (Em) → even stiffness across the tread.</a:t>
+              <a:t>• Manage the uneven-wear risk created by the aramid stiffness step (defensive IP is a real share).</a:t>
             </a:r>
           </a:p>
           <a:p>
@@ -3327,7 +3326,7 @@
               </a:defRPr>
             </a:pPr>
             <a:r>
-              <a:t>• Continental EP2048005B1 (ALIVE): tuned radius-to-width ratios so the stiffness discontinuity doesn't land at wear-initiation sites.</a:t>
+              <a:t>• White space: Nylon-Aramid wear evidence is thin and mostly dead — opportunity, but validate FTO against live PET/PA zoned-density art.</a:t>
             </a:r>
           </a:p>
           <a:p>
@@ -3342,7 +3341,7 @@
               </a:defRPr>
             </a:pPr>
             <a:r>
-              <a:t>• Implication: the defensible path is stiffness PLACEMENT (zoning / grading), not a harder cord — and Continental &amp; Sumitomo already hold live art here.</a:t>
+              <a:t>• Next: pull full claims for the strict Nylon-Aramid set; add rolling-resistance and high-speed-durability axes.</a:t>
             </a:r>
           </a:p>
         </p:txBody>
@@ -3355,7 +3354,7 @@
 </p:sld>
 </file>
 
-<file path=ppt/slides/slide11.xml><?xml version="1.0" encoding="utf-8"?>
+<file path=ppt/slides/slide2.xml><?xml version="1.0" encoding="utf-8"?>
 <p:sld xmlns:a="http://schemas.openxmlformats.org/drawingml/2006/main" xmlns:p="http://schemas.openxmlformats.org/presentationml/2006/main" xmlns:r="http://schemas.openxmlformats.org/officeDocument/2006/relationships">
   <p:cSld>
     <p:spTree>
@@ -3416,7 +3415,7 @@
         </p:nvSpPr>
         <p:spPr>
           <a:xfrm>
-            <a:off x="457200" y="292608"/>
+            <a:off x="457200" y="274320"/>
             <a:ext cx="11247120" cy="822960"/>
           </a:xfrm>
           <a:prstGeom prst="rect">
@@ -3431,14 +3430,14 @@
           <a:lstStyle/>
           <a:p>
             <a:pPr>
-              <a:defRPr sz="2600" b="1">
+              <a:defRPr sz="2500" b="1">
                 <a:solidFill>
                   <a:srgbClr val="1F3B57"/>
                 </a:solidFill>
               </a:defRPr>
             </a:pPr>
             <a:r>
-              <a:t>Takeaways &amp; Recommendations</a:t>
+              <a:t>Scope &amp; Method</a:t>
             </a:r>
           </a:p>
         </p:txBody>
@@ -3476,7 +3475,7 @@
               </a:defRPr>
             </a:pPr>
             <a:r>
-              <a:t>• Wear/mileage is a SECONDARY, indirect benefit of hybrid zero-degree cords — led by stiffness and footprint control.</a:t>
+              <a:t>• PatSeer zero-degree landscape, screened to 1080 passenger-car-radial (PCR) patents — primary motorcycle tires excluded.</a:t>
             </a:r>
           </a:p>
           <a:p>
@@ -3491,7 +3490,37 @@
               </a:defRPr>
             </a:pPr>
             <a:r>
-              <a:t>• For Nylon-Aramid specifically, manage the uneven-wear risk: the stiffness step at the cap-ply edge / over the reinforcing layer drives irregular wear.</a:t>
+              <a:t>• Two hybrid-cord cohorts, defined by EXPLICIT hybrid-cord construction (not mere material co-occurrence):</a:t>
+            </a:r>
+          </a:p>
+          <a:p>
+            <a:pPr>
+              <a:spcAft>
+                <a:spcPts val="500"/>
+              </a:spcAft>
+              <a:defRPr sz="1300">
+                <a:solidFill>
+                  <a:srgbClr val="555555"/>
+                </a:solidFill>
+              </a:defRPr>
+            </a:pPr>
+            <a:r>
+              <a:t>    – General hybrid cords: 156 patents</a:t>
+            </a:r>
+          </a:p>
+          <a:p>
+            <a:pPr>
+              <a:spcAft>
+                <a:spcPts val="500"/>
+              </a:spcAft>
+              <a:defRPr sz="1300">
+                <a:solidFill>
+                  <a:srgbClr val="555555"/>
+                </a:solidFill>
+              </a:defRPr>
+            </a:pPr>
+            <a:r>
+              <a:t>    – Nylon-Aramid cords (focus): 100 patents</a:t>
             </a:r>
           </a:p>
           <a:p>
@@ -3506,7 +3535,7 @@
               </a:defRPr>
             </a:pPr>
             <a:r>
-              <a:t>• Design levers in the IP: dual-modulus cord, twist tuning, adhesion/dip, zoned/two-layer bandage, positioning vs. grooves.</a:t>
+              <a:t>• Wear detection over title/abstract/claims/description + PatSeer AI summaries; 'mileage' is rarely named — this is predominantly a treadwear analysis.</a:t>
             </a:r>
           </a:p>
           <a:p>
@@ -3521,22 +3550,7 @@
               </a:defRPr>
             </a:pPr>
             <a:r>
-              <a:t>• White space is narrow: zoned-density / modulus-grading is the proven path but Continental &amp; Sumitomo hold live art — check freedom-to-operate.</a:t>
-            </a:r>
-          </a:p>
-          <a:p>
-            <a:pPr>
-              <a:spcAft>
-                <a:spcPts val="500"/>
-              </a:spcAft>
-              <a:defRPr sz="1500">
-                <a:solidFill>
-                  <a:srgbClr val="1F3B57"/>
-                </a:solidFill>
-              </a:defRPr>
-            </a:pPr>
-            <a:r>
-              <a:t>• Next: tighten the Nylon-Aramid set to explicit co-twisted constructions; add rolling-resistance and high-speed-durability axes.</a:t>
+              <a:t>• Theme tagging: BENEFIT (wear resistance/mileage) vs. DEFENSIVE (fixing uneven wear). See Limitations slide for caveats.</a:t>
             </a:r>
           </a:p>
         </p:txBody>
@@ -3549,7 +3563,7 @@
 </p:sld>
 </file>
 
-<file path=ppt/slides/slide2.xml><?xml version="1.0" encoding="utf-8"?>
+<file path=ppt/slides/slide3.xml><?xml version="1.0" encoding="utf-8"?>
 <p:sld xmlns:a="http://schemas.openxmlformats.org/drawingml/2006/main" xmlns:p="http://schemas.openxmlformats.org/presentationml/2006/main" xmlns:r="http://schemas.openxmlformats.org/officeDocument/2006/relationships">
   <p:cSld>
     <p:spTree>
@@ -3610,7 +3624,7 @@
         </p:nvSpPr>
         <p:spPr>
           <a:xfrm>
-            <a:off x="457200" y="292608"/>
+            <a:off x="457200" y="274320"/>
             <a:ext cx="11247120" cy="822960"/>
           </a:xfrm>
           <a:prstGeom prst="rect">
@@ -3625,28 +3639,52 @@
           <a:lstStyle/>
           <a:p>
             <a:pPr>
-              <a:defRPr sz="2600" b="1">
+              <a:defRPr sz="2500" b="1">
                 <a:solidFill>
                   <a:srgbClr val="1F3B57"/>
                 </a:solidFill>
               </a:defRPr>
             </a:pPr>
             <a:r>
-              <a:t>Scope &amp; Method</a:t>
-            </a:r>
-          </a:p>
-        </p:txBody>
-      </p:sp>
-      <p:sp>
-        <p:nvSpPr>
-          <p:cNvPr id="4" name="TextBox 3"/>
+              <a:t>Headline Finding</a:t>
+            </a:r>
+          </a:p>
+        </p:txBody>
+      </p:sp>
+      <p:pic>
+        <p:nvPicPr>
+          <p:cNvPr id="4" name="Picture 3" descr="deck_cohorts.png"/>
+          <p:cNvPicPr>
+            <a:picLocks noChangeAspect="1"/>
+          </p:cNvPicPr>
+          <p:nvPr/>
+        </p:nvPicPr>
+        <p:blipFill>
+          <a:blip r:embed="rId2"/>
+          <a:stretch>
+            <a:fillRect/>
+          </a:stretch>
+        </p:blipFill>
+        <p:spPr>
+          <a:xfrm>
+            <a:off x="6217920" y="1463040"/>
+            <a:ext cx="5577840" cy="2929908"/>
+          </a:xfrm>
+          <a:prstGeom prst="rect">
+            <a:avLst/>
+          </a:prstGeom>
+        </p:spPr>
+      </p:pic>
+      <p:sp>
+        <p:nvSpPr>
+          <p:cNvPr id="5" name="TextBox 4"/>
           <p:cNvSpPr txBox="1"/>
           <p:nvPr/>
         </p:nvSpPr>
         <p:spPr>
           <a:xfrm>
-            <a:off x="548640" y="1280160"/>
-            <a:ext cx="11064240" cy="5120640"/>
+            <a:off x="548640" y="1463040"/>
+            <a:ext cx="5486400" cy="4754880"/>
           </a:xfrm>
           <a:prstGeom prst="rect">
             <a:avLst/>
@@ -3670,7 +3708,7 @@
               </a:defRPr>
             </a:pPr>
             <a:r>
-              <a:t>• Source: PatSeer zero-degree belt landscape — 1,816 families, screened to 1,172 passenger-car-radial (PCR) zero-degree (cap-ply / overlay / jointless-band) patents.</a:t>
+              <a:t>• General hybrid: 54 of 156 (35%) make a wear claim.</a:t>
             </a:r>
           </a:p>
           <a:p>
@@ -3685,37 +3723,7 @@
               </a:defRPr>
             </a:pPr>
             <a:r>
-              <a:t>• Two hybrid-cord cohorts defined from patent text:</a:t>
-            </a:r>
-          </a:p>
-          <a:p>
-            <a:pPr>
-              <a:spcAft>
-                <a:spcPts val="500"/>
-              </a:spcAft>
-              <a:defRPr sz="1400">
-                <a:solidFill>
-                  <a:srgbClr val="555555"/>
-                </a:solidFill>
-              </a:defRPr>
-            </a:pPr>
-            <a:r>
-              <a:t>   – General hybrid cords — explicit hybrid wording or any two-material cord co-occurrence:  507 patents</a:t>
-            </a:r>
-          </a:p>
-          <a:p>
-            <a:pPr>
-              <a:spcAft>
-                <a:spcPts val="500"/>
-              </a:spcAft>
-              <a:defRPr sz="1400">
-                <a:solidFill>
-                  <a:srgbClr val="555555"/>
-                </a:solidFill>
-              </a:defRPr>
-            </a:pPr>
-            <a:r>
-              <a:t>   – Nylon-Aramid cords (focus) — aramid + nylon hybrid:  318 patents</a:t>
+              <a:t>• Nylon-Aramid: 31 of 100 (31%) make a wear claim.</a:t>
             </a:r>
           </a:p>
           <a:p>
@@ -3730,7 +3738,7 @@
               </a:defRPr>
             </a:pPr>
             <a:r>
-              <a:t>• Wear/mileage detection: lexicon over title, abstract, claims, description and PatSeer AI summaries.</a:t>
+              <a:t>• Wear is a SECONDARY, indirect benefit — driven by crown stiffness &amp; footprint uniformity, not abrasion chemistry.</a:t>
             </a:r>
           </a:p>
           <a:p>
@@ -3745,22 +3753,7 @@
               </a:defRPr>
             </a:pPr>
             <a:r>
-              <a:t>• Theme tagging: BENEFIT (wear resistance / mileage / tread life) vs. DEFENSIVE (fixing uneven / irregular wear).</a:t>
-            </a:r>
-          </a:p>
-          <a:p>
-            <a:pPr>
-              <a:spcAft>
-                <a:spcPts val="500"/>
-              </a:spcAft>
-              <a:defRPr sz="1600">
-                <a:solidFill>
-                  <a:srgbClr val="1F3B57"/>
-                </a:solidFill>
-              </a:defRPr>
-            </a:pPr>
-            <a:r>
-              <a:t>• Caveat: keyword + co-occurrence based — high recall; verify borderline cases against claims.</a:t>
+              <a:t>• Nylon-Aramid-specific wear evidence is thin (31 patents) — interpret with care.</a:t>
             </a:r>
           </a:p>
         </p:txBody>
@@ -3773,7 +3766,7 @@
 </p:sld>
 </file>
 
-<file path=ppt/slides/slide3.xml><?xml version="1.0" encoding="utf-8"?>
+<file path=ppt/slides/slide4.xml><?xml version="1.0" encoding="utf-8"?>
 <p:sld xmlns:a="http://schemas.openxmlformats.org/drawingml/2006/main" xmlns:p="http://schemas.openxmlformats.org/presentationml/2006/main" xmlns:r="http://schemas.openxmlformats.org/officeDocument/2006/relationships">
   <p:cSld>
     <p:spTree>
@@ -3834,7 +3827,7 @@
         </p:nvSpPr>
         <p:spPr>
           <a:xfrm>
-            <a:off x="457200" y="292608"/>
+            <a:off x="457200" y="274320"/>
             <a:ext cx="11247120" cy="822960"/>
           </a:xfrm>
           <a:prstGeom prst="rect">
@@ -3849,104 +3842,21 @@
           <a:lstStyle/>
           <a:p>
             <a:pPr>
-              <a:defRPr sz="2600" b="1">
+              <a:defRPr sz="2500" b="1">
                 <a:solidFill>
                   <a:srgbClr val="1F3B57"/>
                 </a:solidFill>
               </a:defRPr>
             </a:pPr>
             <a:r>
-              <a:t>Headline Finding</a:t>
-            </a:r>
-          </a:p>
-        </p:txBody>
-      </p:sp>
-      <p:sp>
-        <p:nvSpPr>
-          <p:cNvPr id="4" name="TextBox 3"/>
-          <p:cNvSpPr txBox="1"/>
-          <p:nvPr/>
-        </p:nvSpPr>
-        <p:spPr>
-          <a:xfrm>
-            <a:off x="548640" y="1371600"/>
-            <a:ext cx="5486400" cy="4754880"/>
-          </a:xfrm>
-          <a:prstGeom prst="rect">
-            <a:avLst/>
-          </a:prstGeom>
-          <a:noFill/>
-        </p:spPr>
-        <p:txBody>
-          <a:bodyPr wrap="square">
-            <a:spAutoFit/>
-          </a:bodyPr>
-          <a:lstStyle/>
-          <a:p>
-            <a:pPr>
-              <a:spcAft>
-                <a:spcPts val="500"/>
-              </a:spcAft>
-              <a:defRPr sz="1700">
-                <a:solidFill>
-                  <a:srgbClr val="1F3B57"/>
-                </a:solidFill>
-              </a:defRPr>
-            </a:pPr>
-            <a:r>
-              <a:t>• General hybrid: 199 of 507 (39%) make a wear/mileage claim.</a:t>
-            </a:r>
-          </a:p>
-          <a:p>
-            <a:pPr>
-              <a:spcAft>
-                <a:spcPts val="500"/>
-              </a:spcAft>
-              <a:defRPr sz="1700">
-                <a:solidFill>
-                  <a:srgbClr val="1F3B57"/>
-                </a:solidFill>
-              </a:defRPr>
-            </a:pPr>
-            <a:r>
-              <a:t>• Nylon-Aramid: 115 of 318 (36%) make a wear/mileage claim.</a:t>
-            </a:r>
-          </a:p>
-          <a:p>
-            <a:pPr>
-              <a:spcAft>
-                <a:spcPts val="500"/>
-              </a:spcAft>
-              <a:defRPr sz="1700">
-                <a:solidFill>
-                  <a:srgbClr val="1F3B57"/>
-                </a:solidFill>
-              </a:defRPr>
-            </a:pPr>
-            <a:r>
-              <a:t>• The zero-degree cord is NOT primarily a mileage technology — its wear effect is indirect (crown stiffness &amp; footprint uniformity).</a:t>
-            </a:r>
-          </a:p>
-          <a:p>
-            <a:pPr>
-              <a:spcAft>
-                <a:spcPts val="500"/>
-              </a:spcAft>
-              <a:defRPr sz="1700">
-                <a:solidFill>
-                  <a:srgbClr val="1F3B57"/>
-                </a:solidFill>
-              </a:defRPr>
-            </a:pPr>
-            <a:r>
-              <a:t>• Key difference: Nylon-Aramid skews more DEFENSIVE — a larger share fixes uneven wear the stiff aramid cap ply introduces, rather than claiming a clean mileage win.</a:t>
+              <a:t>Wear Posture — Benefit vs. Fixing Uneven Wear</a:t>
             </a:r>
           </a:p>
         </p:txBody>
       </p:sp>
       <p:pic>
         <p:nvPicPr>
-          <p:cNvPr id="5" name="Picture 4" descr="deck_cohorts.png"/>
+          <p:cNvPr id="4" name="Picture 3" descr="deck_themes.png"/>
           <p:cNvPicPr>
             <a:picLocks noChangeAspect="1"/>
           </p:cNvPicPr>
@@ -3960,14 +3870,97 @@
         </p:blipFill>
         <p:spPr>
           <a:xfrm>
-            <a:off x="6126480" y="1463040"/>
-            <a:ext cx="5669280" cy="3007539"/>
+            <a:off x="640080" y="1371600"/>
+            <a:ext cx="7680960" cy="3104105"/>
           </a:xfrm>
           <a:prstGeom prst="rect">
             <a:avLst/>
           </a:prstGeom>
         </p:spPr>
       </p:pic>
+      <p:sp>
+        <p:nvSpPr>
+          <p:cNvPr id="5" name="TextBox 4"/>
+          <p:cNvSpPr txBox="1"/>
+          <p:nvPr/>
+        </p:nvSpPr>
+        <p:spPr>
+          <a:xfrm>
+            <a:off x="8412480" y="1463040"/>
+            <a:ext cx="3474720" cy="4754880"/>
+          </a:xfrm>
+          <a:prstGeom prst="rect">
+            <a:avLst/>
+          </a:prstGeom>
+          <a:noFill/>
+        </p:spPr>
+        <p:txBody>
+          <a:bodyPr wrap="square">
+            <a:spAutoFit/>
+          </a:bodyPr>
+          <a:lstStyle/>
+          <a:p>
+            <a:pPr>
+              <a:spcAft>
+                <a:spcPts val="500"/>
+              </a:spcAft>
+              <a:defRPr sz="1400">
+                <a:solidFill>
+                  <a:srgbClr val="1F3B57"/>
+                </a:solidFill>
+              </a:defRPr>
+            </a:pPr>
+            <a:r>
+              <a:t>• Each bar = 100% of that cohort's wear patents.</a:t>
+            </a:r>
+          </a:p>
+          <a:p>
+            <a:pPr>
+              <a:spcAft>
+                <a:spcPts val="500"/>
+              </a:spcAft>
+              <a:defRPr sz="1400">
+                <a:solidFill>
+                  <a:srgbClr val="1F3B57"/>
+                </a:solidFill>
+              </a:defRPr>
+            </a:pPr>
+            <a:r>
+              <a:t>• Nylon-Aramid: 6 defensive-only vs 5 'both'.</a:t>
+            </a:r>
+          </a:p>
+          <a:p>
+            <a:pPr>
+              <a:spcAft>
+                <a:spcPts val="500"/>
+              </a:spcAft>
+              <a:defRPr sz="1400">
+                <a:solidFill>
+                  <a:srgbClr val="1F3B57"/>
+                </a:solidFill>
+              </a:defRPr>
+            </a:pPr>
+            <a:r>
+              <a:t>• General hybrid: 29 benefit-only leads.</a:t>
+            </a:r>
+          </a:p>
+          <a:p>
+            <a:pPr>
+              <a:spcAft>
+                <a:spcPts val="500"/>
+              </a:spcAft>
+              <a:defRPr sz="1400">
+                <a:solidFill>
+                  <a:srgbClr val="1F3B57"/>
+                </a:solidFill>
+              </a:defRPr>
+            </a:pPr>
+            <a:r>
+              <a:t>• Stiff aramid helps footprint uniformity but its stiffness step can trigger uneven wear that must be engineered out.</a:t>
+            </a:r>
+          </a:p>
+        </p:txBody>
+      </p:sp>
     </p:spTree>
   </p:cSld>
   <p:clrMapOvr>
@@ -3976,7 +3969,7 @@
 </p:sld>
 </file>
 
-<file path=ppt/slides/slide4.xml><?xml version="1.0" encoding="utf-8"?>
+<file path=ppt/slides/slide5.xml><?xml version="1.0" encoding="utf-8"?>
 <p:sld xmlns:a="http://schemas.openxmlformats.org/drawingml/2006/main" xmlns:p="http://schemas.openxmlformats.org/presentationml/2006/main" xmlns:r="http://schemas.openxmlformats.org/officeDocument/2006/relationships">
   <p:cSld>
     <p:spTree>
@@ -4037,7 +4030,7 @@
         </p:nvSpPr>
         <p:spPr>
           <a:xfrm>
-            <a:off x="457200" y="292608"/>
+            <a:off x="457200" y="274320"/>
             <a:ext cx="11247120" cy="822960"/>
           </a:xfrm>
           <a:prstGeom prst="rect">
@@ -4052,21 +4045,21 @@
           <a:lstStyle/>
           <a:p>
             <a:pPr>
-              <a:defRPr sz="2600" b="1">
+              <a:defRPr sz="2500" b="1">
                 <a:solidFill>
                   <a:srgbClr val="1F3B57"/>
                 </a:solidFill>
               </a:defRPr>
             </a:pPr>
             <a:r>
-              <a:t>Wear Posture — Claiming a Benefit vs. Fixing Uneven Wear</a:t>
+              <a:t>How Nylon-Aramid Tackles Wear (vs. baseline)</a:t>
             </a:r>
           </a:p>
         </p:txBody>
       </p:sp>
       <p:pic>
         <p:nvPicPr>
-          <p:cNvPr id="4" name="Picture 3" descr="deck_themes.png"/>
+          <p:cNvPr id="4" name="Picture 3" descr="deck_solutions.png"/>
           <p:cNvPicPr>
             <a:picLocks noChangeAspect="1"/>
           </p:cNvPicPr>
@@ -4080,8 +4073,8 @@
         </p:blipFill>
         <p:spPr>
           <a:xfrm>
-            <a:off x="640080" y="1371600"/>
-            <a:ext cx="7680960" cy="3257728"/>
+            <a:off x="5760720" y="1325880"/>
+            <a:ext cx="6126480" cy="3270917"/>
           </a:xfrm>
           <a:prstGeom prst="rect">
             <a:avLst/>
@@ -4096,8 +4089,8 @@
         </p:nvSpPr>
         <p:spPr>
           <a:xfrm>
-            <a:off x="8321040" y="1371600"/>
-            <a:ext cx="3566160" cy="4937760"/>
+            <a:off x="548640" y="1554480"/>
+            <a:ext cx="5120640" cy="4572000"/>
           </a:xfrm>
           <a:prstGeom prst="rect">
             <a:avLst/>
@@ -4121,7 +4114,7 @@
               </a:defRPr>
             </a:pPr>
             <a:r>
-              <a:t>• Each bar = 100% of that cohort's wear patents, split by what they claim.</a:t>
+              <a:t>• Compared to all PCR patents, Nylon-Aramid is distinctive in the CORD itself:</a:t>
             </a:r>
           </a:p>
           <a:p>
@@ -4136,7 +4129,7 @@
               </a:defRPr>
             </a:pPr>
             <a:r>
-              <a:t>   – Benefit only = a wear/mileage win, no problem mentioned.</a:t>
+              <a:t>    – Core-sheath / wrap construction (2.0x)</a:t>
             </a:r>
           </a:p>
           <a:p>
@@ -4151,7 +4144,22 @@
               </a:defRPr>
             </a:pPr>
             <a:r>
-              <a:t>   – Defensive = fixes uneven / irregular wear.</a:t>
+              <a:t>    – Graded / dual-modulus cord (1.9x)</a:t>
+            </a:r>
+          </a:p>
+          <a:p>
+            <a:pPr>
+              <a:spcAft>
+                <a:spcPts val="500"/>
+              </a:spcAft>
+              <a:defRPr sz="1200">
+                <a:solidFill>
+                  <a:srgbClr val="555555"/>
+                </a:solidFill>
+              </a:defRPr>
+            </a:pPr>
+            <a:r>
+              <a:t>    – Twist / cord-geometry tuning (1.8x)</a:t>
             </a:r>
           </a:p>
           <a:p>
@@ -4166,37 +4174,7 @@
               </a:defRPr>
             </a:pPr>
             <a:r>
-              <a:t>• Nylon-Aramid is more defensive: 22 defensive-only vs only 10 'both'.</a:t>
-            </a:r>
-          </a:p>
-          <a:p>
-            <a:pPr>
-              <a:spcAft>
-                <a:spcPts val="500"/>
-              </a:spcAft>
-              <a:defRPr sz="1400">
-                <a:solidFill>
-                  <a:srgbClr val="1F3B57"/>
-                </a:solidFill>
-              </a:defRPr>
-            </a:pPr>
-            <a:r>
-              <a:t>• General hybrid is the reverse: 44 'both' vs 24 defensive-only.</a:t>
-            </a:r>
-          </a:p>
-          <a:p>
-            <a:pPr>
-              <a:spcAft>
-                <a:spcPts val="500"/>
-              </a:spcAft>
-              <a:defRPr sz="1400">
-                <a:solidFill>
-                  <a:srgbClr val="1F3B57"/>
-                </a:solidFill>
-              </a:defRPr>
-            </a:pPr>
-            <a:r>
-              <a:t>• Why: stiff aramid helps footprint uniformity, but its stiffness step can trigger uneven wear that must be engineered out.</a:t>
+              <a:t>• Adhesion/dip, two-layer and ZONED density are NOT distinctive to Nylon-Aramid (~1x) — zoned density is a PET/PA story (next slide).</a:t>
             </a:r>
           </a:p>
         </p:txBody>
@@ -4209,7 +4187,7 @@
 </p:sld>
 </file>
 
-<file path=ppt/slides/slide5.xml><?xml version="1.0" encoding="utf-8"?>
+<file path=ppt/slides/slide6.xml><?xml version="1.0" encoding="utf-8"?>
 <p:sld xmlns:a="http://schemas.openxmlformats.org/drawingml/2006/main" xmlns:p="http://schemas.openxmlformats.org/presentationml/2006/main" xmlns:r="http://schemas.openxmlformats.org/officeDocument/2006/relationships">
   <p:cSld>
     <p:spTree>
@@ -4270,7 +4248,7 @@
         </p:nvSpPr>
         <p:spPr>
           <a:xfrm>
-            <a:off x="457200" y="292608"/>
+            <a:off x="457200" y="274320"/>
             <a:ext cx="11247120" cy="822960"/>
           </a:xfrm>
           <a:prstGeom prst="rect">
@@ -4285,52 +4263,28 @@
           <a:lstStyle/>
           <a:p>
             <a:pPr>
-              <a:defRPr sz="2600" b="1">
+              <a:defRPr sz="2500" b="1">
                 <a:solidFill>
                   <a:srgbClr val="1F3B57"/>
                 </a:solidFill>
               </a:defRPr>
             </a:pPr>
             <a:r>
-              <a:t>Claimed Wear Mechanisms</a:t>
-            </a:r>
-          </a:p>
-        </p:txBody>
-      </p:sp>
-      <p:pic>
-        <p:nvPicPr>
-          <p:cNvPr id="4" name="Picture 3" descr="deck_mechanisms.png"/>
-          <p:cNvPicPr>
-            <a:picLocks noChangeAspect="1"/>
-          </p:cNvPicPr>
+              <a:t>Representative Nylon-Aramid Patents</a:t>
+            </a:r>
+          </a:p>
+        </p:txBody>
+      </p:sp>
+      <p:sp>
+        <p:nvSpPr>
+          <p:cNvPr id="4" name="TextBox 3"/>
+          <p:cNvSpPr txBox="1"/>
           <p:nvPr/>
-        </p:nvPicPr>
-        <p:blipFill>
-          <a:blip r:embed="rId2"/>
-          <a:stretch>
-            <a:fillRect/>
-          </a:stretch>
-        </p:blipFill>
+        </p:nvSpPr>
         <p:spPr>
           <a:xfrm>
-            <a:off x="5943600" y="1371600"/>
-            <a:ext cx="5943600" cy="3296170"/>
-          </a:xfrm>
-          <a:prstGeom prst="rect">
-            <a:avLst/>
-          </a:prstGeom>
-        </p:spPr>
-      </p:pic>
-      <p:sp>
-        <p:nvSpPr>
-          <p:cNvPr id="5" name="TextBox 4"/>
-          <p:cNvSpPr txBox="1"/>
-          <p:nvPr/>
-        </p:nvSpPr>
-        <p:spPr>
-          <a:xfrm>
-            <a:off x="548640" y="1554480"/>
-            <a:ext cx="5212080" cy="4389120"/>
+            <a:off x="457200" y="1234440"/>
+            <a:ext cx="11338560" cy="5212080"/>
           </a:xfrm>
           <a:prstGeom prst="rect">
             <a:avLst/>
@@ -4347,14 +4301,14 @@
               <a:spcAft>
                 <a:spcPts val="500"/>
               </a:spcAft>
-              <a:defRPr sz="1600">
+              <a:defRPr sz="1400">
                 <a:solidFill>
                   <a:srgbClr val="1F3B57"/>
                 </a:solidFill>
               </a:defRPr>
             </a:pPr>
             <a:r>
-              <a:t>• Wear effects attributed mainly to cord modulus / material and circumferential rigidity / in-plane shear.</a:t>
+              <a:t>• WO2018230265A1 — BRIDGESTONE CORP (2017, DEAD)</a:t>
             </a:r>
           </a:p>
           <a:p>
@@ -4362,14 +4316,14 @@
               <a:spcAft>
                 <a:spcPts val="500"/>
               </a:spcAft>
-              <a:defRPr sz="1600">
-                <a:solidFill>
-                  <a:srgbClr val="1F3B57"/>
-                </a:solidFill>
-              </a:defRPr>
-            </a:pPr>
-            <a:r>
-              <a:t>• Then growth &amp; tread-profile control and footprint / contact-pressure uniformity.</a:t>
+              <a:defRPr sz="1200">
+                <a:solidFill>
+                  <a:srgbClr val="555555"/>
+                </a:solidFill>
+              </a:defRPr>
+            </a:pPr>
+            <a:r>
+              <a:t>    – The present invention addresses the problem of suppressing the occurrence, in a tire having a spiral cord layer formed by winding a reinforcement cord in a spiral shape, of uneven wear due to the spiral cord layer.</a:t>
             </a:r>
           </a:p>
           <a:p>
@@ -4377,14 +4331,14 @@
               <a:spcAft>
                 <a:spcPts val="500"/>
               </a:spcAft>
-              <a:defRPr sz="1600">
+              <a:defRPr sz="1400">
                 <a:solidFill>
                   <a:srgbClr val="1F3B57"/>
                 </a:solidFill>
               </a:defRPr>
             </a:pPr>
             <a:r>
-              <a:t>• Confirms mechanism is structural (stiffness, footprint) — not tread-compound abrasion chemistry.</a:t>
+              <a:t>• US20040108037A1 — BOOZER MATTHEW (2002, DEAD)</a:t>
             </a:r>
           </a:p>
           <a:p>
@@ -4392,14 +4346,142 @@
               <a:spcAft>
                 <a:spcPts val="500"/>
               </a:spcAft>
-              <a:defRPr sz="1600">
+              <a:defRPr sz="1200">
+                <a:solidFill>
+                  <a:srgbClr val="555555"/>
+                </a:solidFill>
+              </a:defRPr>
+            </a:pPr>
+            <a:r>
+              <a:t>    – The use of high modulus at high stress cords in the second reinforcement plies allows the tire to flatten the transverse curvature at low and moderate speeds, improving wear performance.</a:t>
+            </a:r>
+          </a:p>
+          <a:p>
+            <a:pPr>
+              <a:spcAft>
+                <a:spcPts val="500"/>
+              </a:spcAft>
+              <a:defRPr sz="1400">
                 <a:solidFill>
                   <a:srgbClr val="1F3B57"/>
                 </a:solidFill>
               </a:defRPr>
             </a:pPr>
             <a:r>
-              <a:t>• Patents may count under several mechanisms.</a:t>
+              <a:t>• JP2001163005A — BRIDGESTONE CORP (1999, DEAD)</a:t>
+            </a:r>
+          </a:p>
+          <a:p>
+            <a:pPr>
+              <a:spcAft>
+                <a:spcPts val="500"/>
+              </a:spcAft>
+              <a:defRPr sz="1200">
+                <a:solidFill>
+                  <a:srgbClr val="555555"/>
+                </a:solidFill>
+              </a:defRPr>
+            </a:pPr>
+            <a:r>
+              <a:t>    – The spiral-wound structure of the fiber cord enhances circumferential rigidity and vibration suppression, leading to improved tire contact properties and wear resistance.</a:t>
+            </a:r>
+          </a:p>
+          <a:p>
+            <a:pPr>
+              <a:spcAft>
+                <a:spcPts val="500"/>
+              </a:spcAft>
+              <a:defRPr sz="1400">
+                <a:solidFill>
+                  <a:srgbClr val="1F3B57"/>
+                </a:solidFill>
+              </a:defRPr>
+            </a:pPr>
+            <a:r>
+              <a:t>• WO2019116766A1 — BRIDGESTONE CORP (2017, DEAD)</a:t>
+            </a:r>
+          </a:p>
+          <a:p>
+            <a:pPr>
+              <a:spcAft>
+                <a:spcPts val="500"/>
+              </a:spcAft>
+              <a:defRPr sz="1200">
+                <a:solidFill>
+                  <a:srgbClr val="555555"/>
+                </a:solidFill>
+              </a:defRPr>
+            </a:pPr>
+            <a:r>
+              <a:t>    – METHOD USED</a:t>
+            </a:r>
+            <a:br/>
+            <a:r>
+              <a:t>The invention proposes a hybrid reinforcing member that uses a carbon fiber core and a non-metallic fiber sheath.</a:t>
+            </a:r>
+          </a:p>
+          <a:p>
+            <a:pPr>
+              <a:spcAft>
+                <a:spcPts val="500"/>
+              </a:spcAft>
+              <a:defRPr sz="1400">
+                <a:solidFill>
+                  <a:srgbClr val="1F3B57"/>
+                </a:solidFill>
+              </a:defRPr>
+            </a:pPr>
+            <a:r>
+              <a:t>• WO2015137901A1 — KORDSA GLOBAL ENDUSTRIYEL  (2014, DEAD)</a:t>
+            </a:r>
+          </a:p>
+          <a:p>
+            <a:pPr>
+              <a:spcAft>
+                <a:spcPts val="500"/>
+              </a:spcAft>
+              <a:defRPr sz="1200">
+                <a:solidFill>
+                  <a:srgbClr val="555555"/>
+                </a:solidFill>
+              </a:defRPr>
+            </a:pPr>
+            <a:r>
+              <a:t>    – METHOD USED</a:t>
+            </a:r>
+            <a:br/>
+            <a:r>
+              <a:t>The hybrid cap ply reinforcement layer is constructed by twisting polyethylene terephthalate (PET) and nylon 6.6 multifilament yarns in a specific Z or S direction.</a:t>
+            </a:r>
+          </a:p>
+          <a:p>
+            <a:pPr>
+              <a:spcAft>
+                <a:spcPts val="500"/>
+              </a:spcAft>
+              <a:defRPr sz="1400">
+                <a:solidFill>
+                  <a:srgbClr val="1F3B57"/>
+                </a:solidFill>
+              </a:defRPr>
+            </a:pPr>
+            <a:r>
+              <a:t>• EP2806057A2 — THE GOODYEAR TIRE &amp; RUBBER (2013, ALIVE)</a:t>
+            </a:r>
+          </a:p>
+          <a:p>
+            <a:pPr>
+              <a:spcAft>
+                <a:spcPts val="500"/>
+              </a:spcAft>
+              <a:defRPr sz="1200">
+                <a:solidFill>
+                  <a:srgbClr val="555555"/>
+                </a:solidFill>
+              </a:defRPr>
+            </a:pPr>
+            <a:r>
+              <a:t>    – A hybrid cord having a Nylon core yarn (32) and an Aramid wrap yarn (34) wrapped around the Nylon core yarn (32) is disclosed.</a:t>
             </a:r>
           </a:p>
         </p:txBody>
@@ -4412,7 +4494,7 @@
 </p:sld>
 </file>
 
-<file path=ppt/slides/slide6.xml><?xml version="1.0" encoding="utf-8"?>
+<file path=ppt/slides/slide7.xml><?xml version="1.0" encoding="utf-8"?>
 <p:sld xmlns:a="http://schemas.openxmlformats.org/drawingml/2006/main" xmlns:p="http://schemas.openxmlformats.org/presentationml/2006/main" xmlns:r="http://schemas.openxmlformats.org/officeDocument/2006/relationships">
   <p:cSld>
     <p:spTree>
@@ -4473,7 +4555,7 @@
         </p:nvSpPr>
         <p:spPr>
           <a:xfrm>
-            <a:off x="457200" y="292608"/>
+            <a:off x="457200" y="274320"/>
             <a:ext cx="11247120" cy="822960"/>
           </a:xfrm>
           <a:prstGeom prst="rect">
@@ -4488,52 +4570,28 @@
           <a:lstStyle/>
           <a:p>
             <a:pPr>
-              <a:defRPr sz="2600" b="1">
+              <a:defRPr sz="2500" b="1">
                 <a:solidFill>
                   <a:srgbClr val="1F3B57"/>
                 </a:solidFill>
               </a:defRPr>
             </a:pPr>
             <a:r>
-              <a:t>Who Owns the Nylon-Aramid Wear IP</a:t>
-            </a:r>
-          </a:p>
-        </p:txBody>
-      </p:sp>
-      <p:pic>
-        <p:nvPicPr>
-          <p:cNvPr id="4" name="Picture 3" descr="deck_assignees.png"/>
-          <p:cNvPicPr>
-            <a:picLocks noChangeAspect="1"/>
-          </p:cNvPicPr>
+              <a:t>Related Lever: Zoned Density is PET/PA — not Nylon-Aramid</a:t>
+            </a:r>
+          </a:p>
+        </p:txBody>
+      </p:sp>
+      <p:sp>
+        <p:nvSpPr>
+          <p:cNvPr id="4" name="TextBox 3"/>
+          <p:cNvSpPr txBox="1"/>
           <p:nvPr/>
-        </p:nvPicPr>
-        <p:blipFill>
-          <a:blip r:embed="rId2"/>
-          <a:stretch>
-            <a:fillRect/>
-          </a:stretch>
-        </p:blipFill>
+        </p:nvSpPr>
         <p:spPr>
           <a:xfrm>
-            <a:off x="5943600" y="1371600"/>
-            <a:ext cx="5943600" cy="3059750"/>
-          </a:xfrm>
-          <a:prstGeom prst="rect">
-            <a:avLst/>
-          </a:prstGeom>
-        </p:spPr>
-      </p:pic>
-      <p:sp>
-        <p:nvSpPr>
-          <p:cNvPr id="5" name="TextBox 4"/>
-          <p:cNvSpPr txBox="1"/>
-          <p:nvPr/>
-        </p:nvSpPr>
-        <p:spPr>
-          <a:xfrm>
-            <a:off x="548640" y="1554480"/>
-            <a:ext cx="5212080" cy="4389120"/>
+            <a:off x="548640" y="1280160"/>
+            <a:ext cx="11064240" cy="5120640"/>
           </a:xfrm>
           <a:prstGeom prst="rect">
             <a:avLst/>
@@ -4550,14 +4608,14 @@
               <a:spcAft>
                 <a:spcPts val="500"/>
               </a:spcAft>
-              <a:defRPr sz="1600">
+              <a:defRPr sz="1500">
                 <a:solidFill>
                   <a:srgbClr val="1F3B57"/>
                 </a:solidFill>
               </a:defRPr>
             </a:pPr>
             <a:r>
-              <a:t>• Sumitomo, Bridgestone, Goodyear lead; Continental, AlliedSignal (Honeywell) and Kumho also active.</a:t>
+              <a:t>• Zoned-density bandages (different cord/density centre vs. shoulder) are a real uneven-wear fix — but in PET/PA hybrids, not Nylon-Aramid.</a:t>
             </a:r>
           </a:p>
           <a:p>
@@ -4565,14 +4623,14 @@
               <a:spcAft>
                 <a:spcPts val="500"/>
               </a:spcAft>
-              <a:defRPr sz="1600">
-                <a:solidFill>
-                  <a:srgbClr val="1F3B57"/>
-                </a:solidFill>
-              </a:defRPr>
-            </a:pPr>
-            <a:r>
-              <a:t>• Several Continental and Kumho entries are legally ALIVE — current freedom-to-operate relevance.</a:t>
+              <a:defRPr sz="1300">
+                <a:solidFill>
+                  <a:srgbClr val="555555"/>
+                </a:solidFill>
+              </a:defRPr>
+            </a:pPr>
+            <a:r>
+              <a:t>    – Continental EP3912833A1 (ALIVE): centre PET 120 EPDM + PA4.6 side sections 130 EPDM.</a:t>
             </a:r>
           </a:p>
           <a:p>
@@ -4580,14 +4638,44 @@
               <a:spcAft>
                 <a:spcPts val="500"/>
               </a:spcAft>
-              <a:defRPr sz="1600">
+              <a:defRPr sz="1300">
+                <a:solidFill>
+                  <a:srgbClr val="555555"/>
+                </a:solidFill>
+              </a:defRPr>
+            </a:pPr>
+            <a:r>
+              <a:t>    – Continental DE102016223304B4 (ALIVE): 3-section bandage, centre PA6.6 (470x2) for 'more uniform abrasion'.</a:t>
+            </a:r>
+          </a:p>
+          <a:p>
+            <a:pPr>
+              <a:spcAft>
+                <a:spcPts val="500"/>
+              </a:spcAft>
+              <a:defRPr sz="1500">
                 <a:solidFill>
                   <a:srgbClr val="1F3B57"/>
                 </a:solidFill>
               </a:defRPr>
             </a:pPr>
             <a:r>
-              <a:t>• AlliedSignal patents frame treadwear via in-plane shear modulus of the fiber belt.</a:t>
+              <a:t>• In the Nylon-Aramid cohort zoned density appears in only ~3% (1.3x) — it is NOT the Nylon-Aramid wear lever.</a:t>
+            </a:r>
+          </a:p>
+          <a:p>
+            <a:pPr>
+              <a:spcAft>
+                <a:spcPts val="500"/>
+              </a:spcAft>
+              <a:defRPr sz="1500">
+                <a:solidFill>
+                  <a:srgbClr val="1F3B57"/>
+                </a:solidFill>
+              </a:defRPr>
+            </a:pPr>
+            <a:r>
+              <a:t>• Takeaway: do not attribute the zoned-density wear story to Nylon-Aramid cords.</a:t>
             </a:r>
           </a:p>
         </p:txBody>
@@ -4600,7 +4688,7 @@
 </p:sld>
 </file>
 
-<file path=ppt/slides/slide7.xml><?xml version="1.0" encoding="utf-8"?>
+<file path=ppt/slides/slide8.xml><?xml version="1.0" encoding="utf-8"?>
 <p:sld xmlns:a="http://schemas.openxmlformats.org/drawingml/2006/main" xmlns:p="http://schemas.openxmlformats.org/presentationml/2006/main" xmlns:r="http://schemas.openxmlformats.org/officeDocument/2006/relationships">
   <p:cSld>
     <p:spTree>
@@ -4661,7 +4749,7 @@
         </p:nvSpPr>
         <p:spPr>
           <a:xfrm>
-            <a:off x="457200" y="292608"/>
+            <a:off x="457200" y="274320"/>
             <a:ext cx="11247120" cy="822960"/>
           </a:xfrm>
           <a:prstGeom prst="rect">
@@ -4676,28 +4764,52 @@
           <a:lstStyle/>
           <a:p>
             <a:pPr>
-              <a:defRPr sz="2600" b="1">
+              <a:defRPr sz="2500" b="1">
                 <a:solidFill>
                   <a:srgbClr val="1F3B57"/>
                 </a:solidFill>
               </a:defRPr>
             </a:pPr>
             <a:r>
-              <a:t>Representative Nylon-Aramid Wear Patents</a:t>
-            </a:r>
-          </a:p>
-        </p:txBody>
-      </p:sp>
-      <p:sp>
-        <p:nvSpPr>
-          <p:cNvPr id="4" name="TextBox 3"/>
+              <a:t>Who Owns the Nylon-Aramid IP</a:t>
+            </a:r>
+          </a:p>
+        </p:txBody>
+      </p:sp>
+      <p:pic>
+        <p:nvPicPr>
+          <p:cNvPr id="4" name="Picture 3" descr="deck_assignees.png"/>
+          <p:cNvPicPr>
+            <a:picLocks noChangeAspect="1"/>
+          </p:cNvPicPr>
+          <p:nvPr/>
+        </p:nvPicPr>
+        <p:blipFill>
+          <a:blip r:embed="rId2"/>
+          <a:stretch>
+            <a:fillRect/>
+          </a:stretch>
+        </p:blipFill>
+        <p:spPr>
+          <a:xfrm>
+            <a:off x="5943600" y="1371600"/>
+            <a:ext cx="5943600" cy="3122033"/>
+          </a:xfrm>
+          <a:prstGeom prst="rect">
+            <a:avLst/>
+          </a:prstGeom>
+        </p:spPr>
+      </p:pic>
+      <p:sp>
+        <p:nvSpPr>
+          <p:cNvPr id="5" name="TextBox 4"/>
           <p:cNvSpPr txBox="1"/>
           <p:nvPr/>
         </p:nvSpPr>
         <p:spPr>
           <a:xfrm>
-            <a:off x="457200" y="1234440"/>
-            <a:ext cx="11338560" cy="5212080"/>
+            <a:off x="548640" y="1554480"/>
+            <a:ext cx="5212080" cy="4389120"/>
           </a:xfrm>
           <a:prstGeom prst="rect">
             <a:avLst/>
@@ -4714,14 +4826,14 @@
               <a:spcAft>
                 <a:spcPts val="500"/>
               </a:spcAft>
-              <a:defRPr sz="1400">
+              <a:defRPr sz="1500">
                 <a:solidFill>
                   <a:srgbClr val="1F3B57"/>
                 </a:solidFill>
               </a:defRPr>
             </a:pPr>
             <a:r>
-              <a:t>• EP4335661A1  —  SUMITOMO RUBBER IND LTD  (2022, ALIVE)</a:t>
+              <a:t>• Japanese OEMs (Bridgestone, Sumitomo, Yokohama) plus Goodyear, Michelin, Continental.</a:t>
             </a:r>
           </a:p>
           <a:p>
@@ -4729,14 +4841,14 @@
               <a:spcAft>
                 <a:spcPts val="500"/>
               </a:spcAft>
-              <a:defRPr sz="1200">
-                <a:solidFill>
-                  <a:srgbClr val="555555"/>
-                </a:solidFill>
-              </a:defRPr>
-            </a:pPr>
-            <a:r>
-              <a:t>   – The reinforced belt layer ensures structural integrity and reduces the likelihood of breakage, extending tire life.</a:t>
+              <a:defRPr sz="1500">
+                <a:solidFill>
+                  <a:srgbClr val="1F3B57"/>
+                </a:solidFill>
+              </a:defRPr>
+            </a:pPr>
+            <a:r>
+              <a:t>• Cord makers (Kordsa, Hyosung) appear in the construction patents.</a:t>
             </a:r>
           </a:p>
           <a:p>
@@ -4744,149 +4856,14 @@
               <a:spcAft>
                 <a:spcPts val="500"/>
               </a:spcAft>
-              <a:defRPr sz="1400">
+              <a:defRPr sz="1500">
                 <a:solidFill>
                   <a:srgbClr val="1F3B57"/>
                 </a:solidFill>
               </a:defRPr>
             </a:pPr>
             <a:r>
-              <a:t>• DE102016223304B4  —  CONTINENTAL REIFEN DEUTSCH  (2016, ALIVE)</a:t>
-            </a:r>
-          </a:p>
-          <a:p>
-            <a:pPr>
-              <a:spcAft>
-                <a:spcPts val="500"/>
-              </a:spcAft>
-              <a:defRPr sz="1200">
-                <a:solidFill>
-                  <a:srgbClr val="555555"/>
-                </a:solidFill>
-              </a:defRPr>
-            </a:pPr>
-            <a:r>
-              <a:t>   – The belt bandage is applied in a single layer, with the side sections arranged to provide a more uniform abrasion and improved rolling resistance compared to the center section.</a:t>
-            </a:r>
-          </a:p>
-          <a:p>
-            <a:pPr>
-              <a:spcAft>
-                <a:spcPts val="500"/>
-              </a:spcAft>
-              <a:defRPr sz="1400">
-                <a:solidFill>
-                  <a:srgbClr val="1F3B57"/>
-                </a:solidFill>
-              </a:defRPr>
-            </a:pPr>
-            <a:r>
-              <a:t>• CN106457914A  —  CONTINENTAL REIFEN DEUTSCH  (2014, ALIVE)</a:t>
-            </a:r>
-          </a:p>
-          <a:p>
-            <a:pPr>
-              <a:spcAft>
-                <a:spcPts val="500"/>
-              </a:spcAft>
-              <a:defRPr sz="1200">
-                <a:solidFill>
-                  <a:srgbClr val="555555"/>
-                </a:solidFill>
-              </a:defRPr>
-            </a:pPr>
-            <a:r>
-              <a:t>   – Additionally, conventional belts have limited circumferential stiffness, which can cause uneven wear and reduce tire performance.</a:t>
-            </a:r>
-          </a:p>
-          <a:p>
-            <a:pPr>
-              <a:spcAft>
-                <a:spcPts val="500"/>
-              </a:spcAft>
-              <a:defRPr sz="1400">
-                <a:solidFill>
-                  <a:srgbClr val="1F3B57"/>
-                </a:solidFill>
-              </a:defRPr>
-            </a:pPr>
-            <a:r>
-              <a:t>• KR20130067396A  —  KUMHO TIRE CO INC  (2011, ALIVE)</a:t>
-            </a:r>
-          </a:p>
-          <a:p>
-            <a:pPr>
-              <a:spcAft>
-                <a:spcPts val="500"/>
-              </a:spcAft>
-              <a:defRPr sz="1200">
-                <a:solidFill>
-                  <a:srgbClr val="555555"/>
-                </a:solidFill>
-              </a:defRPr>
-            </a:pPr>
-            <a:r>
-              <a:t>   – The cap ply design allows for even distribution of adhesion forces, preventing uneven wear and maintaining tire integrity.</a:t>
-            </a:r>
-          </a:p>
-          <a:p>
-            <a:pPr>
-              <a:spcAft>
-                <a:spcPts val="500"/>
-              </a:spcAft>
-              <a:defRPr sz="1400">
-                <a:solidFill>
-                  <a:srgbClr val="1F3B57"/>
-                </a:solidFill>
-              </a:defRPr>
-            </a:pPr>
-            <a:r>
-              <a:t>• WO2018230265A1  —  BRIDGESTONE CORP  (2017, DEAD)</a:t>
-            </a:r>
-          </a:p>
-          <a:p>
-            <a:pPr>
-              <a:spcAft>
-                <a:spcPts val="500"/>
-              </a:spcAft>
-              <a:defRPr sz="1200">
-                <a:solidFill>
-                  <a:srgbClr val="555555"/>
-                </a:solidFill>
-              </a:defRPr>
-            </a:pPr>
-            <a:r>
-              <a:t>   – The present invention addresses the problem of suppressing the occurrence, in a tire having a spiral cord layer formed by winding a reinforcement cord in a spiral shape, of uneven wear due to the spiral cord layer.</a:t>
-            </a:r>
-          </a:p>
-          <a:p>
-            <a:pPr>
-              <a:spcAft>
-                <a:spcPts val="500"/>
-              </a:spcAft>
-              <a:defRPr sz="1400">
-                <a:solidFill>
-                  <a:srgbClr val="1F3B57"/>
-                </a:solidFill>
-              </a:defRPr>
-            </a:pPr>
-            <a:r>
-              <a:t>• US20040108037A1  —  BOOZER MATTHEW  (2002, DEAD)</a:t>
-            </a:r>
-          </a:p>
-          <a:p>
-            <a:pPr>
-              <a:spcAft>
-                <a:spcPts val="500"/>
-              </a:spcAft>
-              <a:defRPr sz="1200">
-                <a:solidFill>
-                  <a:srgbClr val="555555"/>
-                </a:solidFill>
-              </a:defRPr>
-            </a:pPr>
-            <a:r>
-              <a:t>   – The use of high modulus at high stress cords in the second reinforcement plies allows the tire to flatten the transverse curvature at low and moderate speeds, improving wear performance.</a:t>
+              <a:t>• Most Nylon-Aramid wear patents are legally DEAD — limited live art on the wear angle specifically.</a:t>
             </a:r>
           </a:p>
         </p:txBody>
@@ -4899,7 +4876,7 @@
 </p:sld>
 </file>
 
-<file path=ppt/slides/slide8.xml><?xml version="1.0" encoding="utf-8"?>
+<file path=ppt/slides/slide9.xml><?xml version="1.0" encoding="utf-8"?>
 <p:sld xmlns:a="http://schemas.openxmlformats.org/drawingml/2006/main" xmlns:p="http://schemas.openxmlformats.org/presentationml/2006/main" xmlns:r="http://schemas.openxmlformats.org/officeDocument/2006/relationships">
   <p:cSld>
     <p:spTree>
@@ -4960,7 +4937,7 @@
         </p:nvSpPr>
         <p:spPr>
           <a:xfrm>
-            <a:off x="457200" y="292608"/>
+            <a:off x="457200" y="274320"/>
             <a:ext cx="11247120" cy="822960"/>
           </a:xfrm>
           <a:prstGeom prst="rect">
@@ -4975,52 +4952,28 @@
           <a:lstStyle/>
           <a:p>
             <a:pPr>
-              <a:defRPr sz="2600" b="1">
+              <a:defRPr sz="2500" b="1">
                 <a:solidFill>
                   <a:srgbClr val="1F3B57"/>
                 </a:solidFill>
               </a:defRPr>
             </a:pPr>
             <a:r>
-              <a:t>Deep Dive — How Nylon-Aramid Patents Solve Wear</a:t>
-            </a:r>
-          </a:p>
-        </p:txBody>
-      </p:sp>
-      <p:pic>
-        <p:nvPicPr>
-          <p:cNvPr id="4" name="Picture 3" descr="deck_solutions.png"/>
-          <p:cNvPicPr>
-            <a:picLocks noChangeAspect="1"/>
-          </p:cNvPicPr>
+              <a:t>Limitations &amp; Methodology (read before citing)</a:t>
+            </a:r>
+          </a:p>
+        </p:txBody>
+      </p:sp>
+      <p:sp>
+        <p:nvSpPr>
+          <p:cNvPr id="4" name="TextBox 3"/>
+          <p:cNvSpPr txBox="1"/>
           <p:nvPr/>
-        </p:nvPicPr>
-        <p:blipFill>
-          <a:blip r:embed="rId2"/>
-          <a:stretch>
-            <a:fillRect/>
-          </a:stretch>
-        </p:blipFill>
+        </p:nvSpPr>
         <p:spPr>
           <a:xfrm>
-            <a:off x="5852160" y="1280160"/>
-            <a:ext cx="6035040" cy="3165024"/>
-          </a:xfrm>
-          <a:prstGeom prst="rect">
-            <a:avLst/>
-          </a:prstGeom>
-        </p:spPr>
-      </p:pic>
-      <p:sp>
-        <p:nvSpPr>
-          <p:cNvPr id="5" name="TextBox 4"/>
-          <p:cNvSpPr txBox="1"/>
-          <p:nvPr/>
-        </p:nvSpPr>
-        <p:spPr>
-          <a:xfrm>
-            <a:off x="548640" y="1463040"/>
-            <a:ext cx="5029200" cy="4754880"/>
+            <a:off x="548640" y="1234440"/>
+            <a:ext cx="11155680" cy="5303520"/>
           </a:xfrm>
           <a:prstGeom prst="rect">
             <a:avLst/>
@@ -5037,180 +4990,16 @@
               <a:spcAft>
                 <a:spcPts val="500"/>
               </a:spcAft>
-              <a:defRPr sz="1500">
+              <a:defRPr sz="1400">
                 <a:solidFill>
                   <a:srgbClr val="1F3B57"/>
                 </a:solidFill>
               </a:defRPr>
             </a:pPr>
             <a:r>
-              <a:t>• Researchers rarely chase abrasion resistance directly.</a:t>
-            </a:r>
-          </a:p>
-          <a:p>
-            <a:pPr>
-              <a:spcAft>
-                <a:spcPts val="500"/>
-              </a:spcAft>
-              <a:defRPr sz="1500">
-                <a:solidFill>
-                  <a:srgbClr val="1F3B57"/>
-                </a:solidFill>
-              </a:defRPr>
-            </a:pPr>
-            <a:r>
-              <a:t>• The strategy: make the contact patch uniform &amp; dimensionally stable.</a:t>
-            </a:r>
-          </a:p>
-          <a:p>
-            <a:pPr>
-              <a:spcAft>
-                <a:spcPts val="500"/>
-              </a:spcAft>
-              <a:defRPr sz="1500">
-                <a:solidFill>
-                  <a:srgbClr val="1F3B57"/>
-                </a:solidFill>
-              </a:defRPr>
-            </a:pPr>
-            <a:r>
-              <a:t>• Aramid gives hoop stiffness → restrains crown growth → stable tread geometry → less slip/squirm wear.</a:t>
-            </a:r>
-          </a:p>
-          <a:p>
-            <a:pPr>
-              <a:spcAft>
-                <a:spcPts val="500"/>
-              </a:spcAft>
-              <a:defRPr sz="1500">
-                <a:solidFill>
-                  <a:srgbClr val="1F3B57"/>
-                </a:solidFill>
-              </a:defRPr>
-            </a:pPr>
-            <a:r>
-              <a:t>• But aramid's stiffness step itself causes uneven wear — so most IP is about placing &amp; grading that stiffness.</a:t>
-            </a:r>
-          </a:p>
-        </p:txBody>
-      </p:sp>
-    </p:spTree>
-  </p:cSld>
-  <p:clrMapOvr>
-    <a:masterClrMapping/>
-  </p:clrMapOvr>
-</p:sld>
-</file>
-
-<file path=ppt/slides/slide9.xml><?xml version="1.0" encoding="utf-8"?>
-<p:sld xmlns:a="http://schemas.openxmlformats.org/drawingml/2006/main" xmlns:p="http://schemas.openxmlformats.org/presentationml/2006/main" xmlns:r="http://schemas.openxmlformats.org/officeDocument/2006/relationships">
-  <p:cSld>
-    <p:spTree>
-      <p:nvGrpSpPr>
-        <p:cNvPr id="1" name=""/>
-        <p:cNvGrpSpPr/>
-        <p:nvPr/>
-      </p:nvGrpSpPr>
-      <p:grpSpPr/>
-      <p:sp>
-        <p:nvSpPr>
-          <p:cNvPr id="2" name="Rectangle 1"/>
-          <p:cNvSpPr/>
-          <p:nvPr/>
-        </p:nvSpPr>
-        <p:spPr>
-          <a:xfrm>
-            <a:off x="0" y="0"/>
-            <a:ext cx="12191695" cy="164592"/>
-          </a:xfrm>
-          <a:prstGeom prst="rect">
-            <a:avLst/>
-          </a:prstGeom>
-          <a:solidFill>
-            <a:srgbClr val="1F3B57"/>
-          </a:solidFill>
-          <a:ln>
-            <a:noFill/>
-          </a:ln>
-        </p:spPr>
-        <p:style>
-          <a:lnRef idx="1">
-            <a:schemeClr val="accent1"/>
-          </a:lnRef>
-          <a:fillRef idx="3">
-            <a:schemeClr val="accent1"/>
-          </a:fillRef>
-          <a:effectRef idx="2">
-            <a:schemeClr val="accent1"/>
-          </a:effectRef>
-          <a:fontRef idx="minor">
-            <a:schemeClr val="lt1"/>
-          </a:fontRef>
-        </p:style>
-        <p:txBody>
-          <a:bodyPr rtlCol="0" anchor="ctr"/>
-          <a:lstStyle/>
-          <a:p>
-            <a:pPr algn="ctr"/>
-          </a:p>
-        </p:txBody>
-      </p:sp>
-      <p:sp>
-        <p:nvSpPr>
-          <p:cNvPr id="3" name="TextBox 2"/>
-          <p:cNvSpPr txBox="1"/>
-          <p:nvPr/>
-        </p:nvSpPr>
-        <p:spPr>
-          <a:xfrm>
-            <a:off x="457200" y="292608"/>
-            <a:ext cx="11247120" cy="822960"/>
-          </a:xfrm>
-          <a:prstGeom prst="rect">
-            <a:avLst/>
-          </a:prstGeom>
-          <a:noFill/>
-        </p:spPr>
-        <p:txBody>
-          <a:bodyPr wrap="square">
-            <a:spAutoFit/>
-          </a:bodyPr>
-          <a:lstStyle/>
-          <a:p>
-            <a:pPr>
-              <a:defRPr sz="2600" b="1">
-                <a:solidFill>
-                  <a:srgbClr val="1F3B57"/>
-                </a:solidFill>
-              </a:defRPr>
-            </a:pPr>
-            <a:r>
-              <a:t>Five Recurring Engineering Solutions</a:t>
-            </a:r>
-          </a:p>
-        </p:txBody>
-      </p:sp>
-      <p:sp>
-        <p:nvSpPr>
-          <p:cNvPr id="4" name="TextBox 3"/>
-          <p:cNvSpPr txBox="1"/>
-          <p:nvPr/>
-        </p:nvSpPr>
-        <p:spPr>
-          <a:xfrm>
-            <a:off x="548640" y="1234440"/>
-            <a:ext cx="11155680" cy="5212080"/>
-          </a:xfrm>
-          <a:prstGeom prst="rect">
-            <a:avLst/>
-          </a:prstGeom>
-          <a:noFill/>
-        </p:spPr>
-        <p:txBody>
-          <a:bodyPr wrap="square">
-            <a:spAutoFit/>
-          </a:bodyPr>
-          <a:lstStyle/>
+              <a:t>• Cohorts are text-mined (PatSeer fields + AI summaries) with high recall; spot-check before quoting individual patents.</a:t>
+            </a:r>
+          </a:p>
           <a:p>
             <a:pPr>
               <a:spcAft>
@@ -5223,22 +5012,7 @@
               </a:defRPr>
             </a:pPr>
             <a:r>
-              <a:t>• 1. Dual-modulus / core-sheath cord (51%) — low-mod core (nylon/rayon/PET) + high-mod aramid sheath; soft to build, stiff in service.</a:t>
-            </a:r>
-          </a:p>
-          <a:p>
-            <a:pPr>
-              <a:spcAft>
-                <a:spcPts val="500"/>
-              </a:spcAft>
-              <a:defRPr sz="1200">
-                <a:solidFill>
-                  <a:srgbClr val="555555"/>
-                </a:solidFill>
-              </a:defRPr>
-            </a:pPr>
-            <a:r>
-              <a:t>   – Goodyear EP2380755A2 (ALIVE): low-modulus core, 5–15 TPI, high-modulus outer filament.</a:t>
+              <a:t>• 'Nylon-Aramid' = explicit aramid+nylon hybrid-cord construction. A looser co-occurrence rule inflated this ~3x (318 -&gt; 100); the strict figure is used here.</a:t>
             </a:r>
           </a:p>
           <a:p>
@@ -5253,7 +5027,7 @@
               </a:defRPr>
             </a:pPr>
             <a:r>
-              <a:t>• 2. Twist / cord-geometry tuning (64%) — twist, denier, filament count set where the modulus transition occurs.</a:t>
+              <a:t>• 92 primary motorcycle tires were removed; some patents still mention motorcycle as a secondary application.</a:t>
             </a:r>
           </a:p>
           <a:p>
@@ -5268,22 +5042,7 @@
               </a:defRPr>
             </a:pPr>
             <a:r>
-              <a:t>• 3. Adhesion / dip engineering (61%) — epoxy pre-dip + RFL; less cord-rubber slip → less wear &amp; edge separation.</a:t>
-            </a:r>
-          </a:p>
-          <a:p>
-            <a:pPr>
-              <a:spcAft>
-                <a:spcPts val="500"/>
-              </a:spcAft>
-              <a:defRPr sz="1200">
-                <a:solidFill>
-                  <a:srgbClr val="555555"/>
-                </a:solidFill>
-              </a:defRPr>
-            </a:pPr>
-            <a:r>
-              <a:t>   – Goodyear US20160288575A1: single-end-dipped (SED) cords, no calendering.</a:t>
+              <a:t>• Solution percentages are multi-label and shown as ENRICHMENT vs. baseline to avoid overstating common vocabulary.</a:t>
             </a:r>
           </a:p>
           <a:p>
@@ -5298,7 +5057,7 @@
               </a:defRPr>
             </a:pPr>
             <a:r>
-              <a:t>• 4. Zoned / two-layer overlay (46%) — different cord/density across tread width to equalise contact pressure (the uneven-wear fix).</a:t>
+              <a:t>• Wear is predominantly treadwear, not 'mileage' (named in only ~12 patents).</a:t>
             </a:r>
           </a:p>
           <a:p>
@@ -5313,7 +5072,7 @@
               </a:defRPr>
             </a:pPr>
             <a:r>
-              <a:t>• 5. Positioning vs. grooves &amp; geometry ratios (20%) — keep the stiffness step away from where wear initiates.</a:t>
+              <a:t>• Corpus skews pre-2015; legal status reflects the export date.</a:t>
             </a:r>
           </a:p>
         </p:txBody>

</xml_diff>